<commit_message>
Expand PPT with academic framing and analysis
Co-authored-by: maotianyi12138-eng <maotianyi12138-eng@users.noreply.github.com>
</commit_message>
<xml_diff>
--- a/Finding_Direction_Through_Exploration_Bauhaus.pptx
+++ b/Finding_Direction_Through_Exploration_Bauhaus.pptx
@@ -3320,7 +3320,7 @@
         <p:spPr>
           <a:xfrm>
             <a:off x="0" y="384048"/>
-            <a:ext cx="2011680" cy="6492240"/>
+            <a:ext cx="2057400" cy="6473952"/>
           </a:xfrm>
           <a:prstGeom prst="rect">
             <a:avLst/>
@@ -3362,8 +3362,8 @@
         </p:nvSpPr>
         <p:spPr>
           <a:xfrm>
-            <a:off x="2011680" y="5120640"/>
-            <a:ext cx="2743200" cy="1737360"/>
+            <a:off x="2057400" y="5074920"/>
+            <a:ext cx="2788920" cy="1783080"/>
           </a:xfrm>
           <a:prstGeom prst="rect">
             <a:avLst/>
@@ -3405,8 +3405,8 @@
         </p:nvSpPr>
         <p:spPr>
           <a:xfrm>
-            <a:off x="10058400" y="731520"/>
-            <a:ext cx="1828800" cy="1828800"/>
+            <a:off x="10012680" y="713232"/>
+            <a:ext cx="1874519" cy="1874519"/>
           </a:xfrm>
           <a:prstGeom prst="ellipse">
             <a:avLst/>
@@ -3448,8 +3448,8 @@
         </p:nvSpPr>
         <p:spPr>
           <a:xfrm>
-            <a:off x="2286000" y="1920240"/>
-            <a:ext cx="8138160" cy="2011680"/>
+            <a:off x="2286000" y="1737360"/>
+            <a:ext cx="8229600" cy="2148840"/>
           </a:xfrm>
           <a:prstGeom prst="rect">
             <a:avLst/>
@@ -3463,7 +3463,7 @@
           <a:lstStyle/>
           <a:p>
             <a:pPr>
-              <a:defRPr sz="5200" b="1">
+              <a:defRPr sz="4800" b="1">
                 <a:solidFill>
                   <a:srgbClr val="181818"/>
                 </a:solidFill>
@@ -3472,6 +3472,19 @@
             </a:pPr>
             <a:r>
               <a:t>Finding Direction Through Exploration</a:t>
+            </a:r>
+          </a:p>
+          <a:p>
+            <a:pPr>
+              <a:defRPr sz="2200" b="1">
+                <a:solidFill>
+                  <a:srgbClr val="3263BE"/>
+                </a:solidFill>
+                <a:latin typeface="Arial"/>
+              </a:defRPr>
+            </a:pPr>
+            <a:r>
+              <a:t>Extended Study Plan (Academic Version)</a:t>
             </a:r>
           </a:p>
         </p:txBody>
@@ -3484,8 +3497,8 @@
         </p:nvSpPr>
         <p:spPr>
           <a:xfrm>
-            <a:off x="2331720" y="4206240"/>
-            <a:ext cx="7772400" cy="1463040"/>
+            <a:off x="2331720" y="4297680"/>
+            <a:ext cx="7955279" cy="1554480"/>
           </a:xfrm>
           <a:prstGeom prst="rect">
             <a:avLst/>
@@ -3499,7 +3512,7 @@
           <a:lstStyle/>
           <a:p>
             <a:pPr>
-              <a:defRPr sz="2200" b="1">
+              <a:defRPr sz="2100" b="1">
                 <a:solidFill>
                   <a:srgbClr val="181818"/>
                 </a:solidFill>
@@ -3780,8 +3793,8 @@
         </p:nvSpPr>
         <p:spPr>
           <a:xfrm>
-            <a:off x="731520" y="685800"/>
-            <a:ext cx="10789920" cy="868680"/>
+            <a:off x="731520" y="676656"/>
+            <a:ext cx="10972800" cy="868680"/>
           </a:xfrm>
           <a:prstGeom prst="rect">
             <a:avLst/>
@@ -3795,7 +3808,7 @@
           <a:lstStyle/>
           <a:p>
             <a:pPr>
-              <a:defRPr sz="3800" b="1">
+              <a:defRPr sz="3500" b="1">
                 <a:solidFill>
                   <a:srgbClr val="181818"/>
                 </a:solidFill>
@@ -3816,8 +3829,8 @@
         </p:nvSpPr>
         <p:spPr>
           <a:xfrm>
-            <a:off x="731520" y="1536192"/>
-            <a:ext cx="2926080" cy="82296"/>
+            <a:off x="731520" y="1517904"/>
+            <a:ext cx="3017520" cy="82296"/>
           </a:xfrm>
           <a:prstGeom prst="rect">
             <a:avLst/>
@@ -3859,8 +3872,8 @@
         </p:nvSpPr>
         <p:spPr>
           <a:xfrm>
-            <a:off x="9875520" y="5029200"/>
-            <a:ext cx="1097280" cy="1097280"/>
+            <a:off x="9784080" y="4892040"/>
+            <a:ext cx="1188720" cy="1188720"/>
           </a:xfrm>
           <a:prstGeom prst="ellipse">
             <a:avLst/>
@@ -3902,8 +3915,8 @@
         </p:nvSpPr>
         <p:spPr>
           <a:xfrm>
-            <a:off x="10515600" y="4389120"/>
-            <a:ext cx="1463040" cy="1463040"/>
+            <a:off x="10469880" y="4251960"/>
+            <a:ext cx="1508760" cy="1508760"/>
           </a:xfrm>
           <a:prstGeom prst="ellipse">
             <a:avLst/>
@@ -3945,8 +3958,8 @@
         </p:nvSpPr>
         <p:spPr>
           <a:xfrm>
-            <a:off x="8869680" y="5760720"/>
-            <a:ext cx="1828800" cy="228600"/>
+            <a:off x="8823960" y="5715000"/>
+            <a:ext cx="1965960" cy="256032"/>
           </a:xfrm>
           <a:prstGeom prst="rect">
             <a:avLst/>
@@ -3988,8 +4001,8 @@
         </p:nvSpPr>
         <p:spPr>
           <a:xfrm>
-            <a:off x="868680" y="1920240"/>
-            <a:ext cx="4114800" cy="365760"/>
+            <a:off x="868680" y="1783080"/>
+            <a:ext cx="10424160" cy="384048"/>
           </a:xfrm>
           <a:prstGeom prst="rect">
             <a:avLst/>
@@ -4003,7 +4016,7 @@
           <a:lstStyle/>
           <a:p>
             <a:pPr>
-              <a:defRPr sz="2400" b="1">
+              <a:defRPr sz="1900" b="1">
                 <a:solidFill>
                   <a:srgbClr val="3263BE"/>
                 </a:solidFill>
@@ -4011,7 +4024,7 @@
               </a:defRPr>
             </a:pPr>
             <a:r>
-              <a:t>My core goals for the Extended Study are:</a:t>
+              <a:t>Research Context</a:t>
             </a:r>
           </a:p>
         </p:txBody>
@@ -4024,8 +4037,8 @@
         </p:nvSpPr>
         <p:spPr>
           <a:xfrm>
-            <a:off x="960120" y="2304288"/>
-            <a:ext cx="10332720" cy="1325880"/>
+            <a:off x="987552" y="2112264"/>
+            <a:ext cx="10104120" cy="603503"/>
           </a:xfrm>
           <a:prstGeom prst="rect">
             <a:avLst/>
@@ -4040,9 +4053,9 @@
           <a:p>
             <a:pPr>
               <a:spcAft>
-                <a:spcPts val="600"/>
+                <a:spcPts val="200"/>
               </a:spcAft>
-              <a:defRPr sz="2000">
+              <a:defRPr sz="1400">
                 <a:solidFill>
                   <a:srgbClr val="181818"/>
                 </a:solidFill>
@@ -4050,15 +4063,15 @@
               </a:defRPr>
             </a:pPr>
             <a:r>
-              <a:t>• To better use AI tools for creative design practice.</a:t>
+              <a:t>• AI-assisted design is reshaping creative workflows and role expectations in communication industries.</a:t>
             </a:r>
           </a:p>
           <a:p>
             <a:pPr>
               <a:spcAft>
-                <a:spcPts val="600"/>
+                <a:spcPts val="200"/>
               </a:spcAft>
-              <a:defRPr sz="2000">
+              <a:defRPr sz="1400">
                 <a:solidFill>
                   <a:srgbClr val="181818"/>
                 </a:solidFill>
@@ -4066,15 +4079,74 @@
               </a:defRPr>
             </a:pPr>
             <a:r>
-              <a:t>• To find my true passion and professional direction.</a:t>
-            </a:r>
-          </a:p>
+              <a:t>• This study adopts a practice-led perspective to connect tool competence with professional identity formation.</a:t>
+            </a:r>
+          </a:p>
+        </p:txBody>
+      </p:sp>
+      <p:sp>
+        <p:nvSpPr>
+          <p:cNvPr id="14" name="TextBox 13"/>
+          <p:cNvSpPr txBox="1"/>
+          <p:nvPr/>
+        </p:nvSpPr>
+        <p:spPr>
+          <a:xfrm>
+            <a:off x="868680" y="2788920"/>
+            <a:ext cx="10424160" cy="384048"/>
+          </a:xfrm>
+          <a:prstGeom prst="rect">
+            <a:avLst/>
+          </a:prstGeom>
+          <a:noFill/>
+        </p:spPr>
+        <p:txBody>
+          <a:bodyPr wrap="none">
+            <a:spAutoFit/>
+          </a:bodyPr>
+          <a:lstStyle/>
+          <a:p>
+            <a:pPr>
+              <a:defRPr sz="1900" b="1">
+                <a:solidFill>
+                  <a:srgbClr val="3263BE"/>
+                </a:solidFill>
+                <a:latin typeface="Futura"/>
+              </a:defRPr>
+            </a:pPr>
+            <a:r>
+              <a:t>Core Objectives</a:t>
+            </a:r>
+          </a:p>
+        </p:txBody>
+      </p:sp>
+      <p:sp>
+        <p:nvSpPr>
+          <p:cNvPr id="15" name="TextBox 14"/>
+          <p:cNvSpPr txBox="1"/>
+          <p:nvPr/>
+        </p:nvSpPr>
+        <p:spPr>
+          <a:xfrm>
+            <a:off x="987552" y="3118103"/>
+            <a:ext cx="10104120" cy="877824"/>
+          </a:xfrm>
+          <a:prstGeom prst="rect">
+            <a:avLst/>
+          </a:prstGeom>
+          <a:noFill/>
+        </p:spPr>
+        <p:txBody>
+          <a:bodyPr wrap="none">
+            <a:spAutoFit/>
+          </a:bodyPr>
+          <a:lstStyle/>
           <a:p>
             <a:pPr>
               <a:spcAft>
-                <a:spcPts val="600"/>
+                <a:spcPts val="200"/>
               </a:spcAft>
-              <a:defRPr sz="2000">
+              <a:defRPr sz="1400">
                 <a:solidFill>
                   <a:srgbClr val="181818"/>
                 </a:solidFill>
@@ -4082,7 +4154,130 @@
               </a:defRPr>
             </a:pPr>
             <a:r>
-              <a:t>• To gain real work experience in creative industries.</a:t>
+              <a:t>• Develop advanced and critical use of AI tools in creative design practice.</a:t>
+            </a:r>
+          </a:p>
+          <a:p>
+            <a:pPr>
+              <a:spcAft>
+                <a:spcPts val="200"/>
+              </a:spcAft>
+              <a:defRPr sz="1400">
+                <a:solidFill>
+                  <a:srgbClr val="181818"/>
+                </a:solidFill>
+                <a:latin typeface="Arial"/>
+              </a:defRPr>
+            </a:pPr>
+            <a:r>
+              <a:t>• Identify a sustainable professional direction that aligns with my values and strengths.</a:t>
+            </a:r>
+          </a:p>
+          <a:p>
+            <a:pPr>
+              <a:spcAft>
+                <a:spcPts val="200"/>
+              </a:spcAft>
+              <a:defRPr sz="1400">
+                <a:solidFill>
+                  <a:srgbClr val="181818"/>
+                </a:solidFill>
+                <a:latin typeface="Arial"/>
+              </a:defRPr>
+            </a:pPr>
+            <a:r>
+              <a:t>• Gain industry-facing experience in real production contexts.</a:t>
+            </a:r>
+          </a:p>
+        </p:txBody>
+      </p:sp>
+      <p:sp>
+        <p:nvSpPr>
+          <p:cNvPr id="16" name="TextBox 15"/>
+          <p:cNvSpPr txBox="1"/>
+          <p:nvPr/>
+        </p:nvSpPr>
+        <p:spPr>
+          <a:xfrm>
+            <a:off x="868680" y="4069079"/>
+            <a:ext cx="10424160" cy="384048"/>
+          </a:xfrm>
+          <a:prstGeom prst="rect">
+            <a:avLst/>
+          </a:prstGeom>
+          <a:noFill/>
+        </p:spPr>
+        <p:txBody>
+          <a:bodyPr wrap="none">
+            <a:spAutoFit/>
+          </a:bodyPr>
+          <a:lstStyle/>
+          <a:p>
+            <a:pPr>
+              <a:defRPr sz="1900" b="1">
+                <a:solidFill>
+                  <a:srgbClr val="3263BE"/>
+                </a:solidFill>
+                <a:latin typeface="Futura"/>
+              </a:defRPr>
+            </a:pPr>
+            <a:r>
+              <a:t>Guiding Questions</a:t>
+            </a:r>
+          </a:p>
+        </p:txBody>
+      </p:sp>
+      <p:sp>
+        <p:nvSpPr>
+          <p:cNvPr id="17" name="TextBox 16"/>
+          <p:cNvSpPr txBox="1"/>
+          <p:nvPr/>
+        </p:nvSpPr>
+        <p:spPr>
+          <a:xfrm>
+            <a:off x="987552" y="4398264"/>
+            <a:ext cx="10104120" cy="603503"/>
+          </a:xfrm>
+          <a:prstGeom prst="rect">
+            <a:avLst/>
+          </a:prstGeom>
+          <a:noFill/>
+        </p:spPr>
+        <p:txBody>
+          <a:bodyPr wrap="none">
+            <a:spAutoFit/>
+          </a:bodyPr>
+          <a:lstStyle/>
+          <a:p>
+            <a:pPr>
+              <a:spcAft>
+                <a:spcPts val="200"/>
+              </a:spcAft>
+              <a:defRPr sz="1400">
+                <a:solidFill>
+                  <a:srgbClr val="181818"/>
+                </a:solidFill>
+                <a:latin typeface="Arial"/>
+              </a:defRPr>
+            </a:pPr>
+            <a:r>
+              <a:t>• How can AI be integrated into end-to-end creative workflow while preserving design authorship?</a:t>
+            </a:r>
+          </a:p>
+          <a:p>
+            <a:pPr>
+              <a:spcAft>
+                <a:spcPts val="200"/>
+              </a:spcAft>
+              <a:defRPr sz="1400">
+                <a:solidFill>
+                  <a:srgbClr val="181818"/>
+                </a:solidFill>
+                <a:latin typeface="Arial"/>
+              </a:defRPr>
+            </a:pPr>
+            <a:r>
+              <a:t>• Which pathway best connects my current skills with long-term opportunities in China?</a:t>
             </a:r>
           </a:p>
         </p:txBody>
@@ -4329,8 +4524,8 @@
         </p:nvSpPr>
         <p:spPr>
           <a:xfrm>
-            <a:off x="731520" y="685800"/>
-            <a:ext cx="10789920" cy="868680"/>
+            <a:off x="731520" y="676656"/>
+            <a:ext cx="10972800" cy="868680"/>
           </a:xfrm>
           <a:prstGeom prst="rect">
             <a:avLst/>
@@ -4344,7 +4539,7 @@
           <a:lstStyle/>
           <a:p>
             <a:pPr>
-              <a:defRPr sz="3800" b="1">
+              <a:defRPr sz="3500" b="1">
                 <a:solidFill>
                   <a:srgbClr val="181818"/>
                 </a:solidFill>
@@ -4365,8 +4560,8 @@
         </p:nvSpPr>
         <p:spPr>
           <a:xfrm>
-            <a:off x="731520" y="1536192"/>
-            <a:ext cx="2926080" cy="82296"/>
+            <a:off x="731520" y="1517904"/>
+            <a:ext cx="3017520" cy="82296"/>
           </a:xfrm>
           <a:prstGeom prst="rect">
             <a:avLst/>
@@ -4408,8 +4603,8 @@
         </p:nvSpPr>
         <p:spPr>
           <a:xfrm>
-            <a:off x="9875520" y="5029200"/>
-            <a:ext cx="1097280" cy="1097280"/>
+            <a:off x="9784080" y="4892040"/>
+            <a:ext cx="1188720" cy="1188720"/>
           </a:xfrm>
           <a:prstGeom prst="ellipse">
             <a:avLst/>
@@ -4451,8 +4646,8 @@
         </p:nvSpPr>
         <p:spPr>
           <a:xfrm>
-            <a:off x="10515600" y="4389120"/>
-            <a:ext cx="1463040" cy="1463040"/>
+            <a:off x="10469880" y="4251960"/>
+            <a:ext cx="1508760" cy="1508760"/>
           </a:xfrm>
           <a:prstGeom prst="ellipse">
             <a:avLst/>
@@ -4494,8 +4689,8 @@
         </p:nvSpPr>
         <p:spPr>
           <a:xfrm>
-            <a:off x="8869680" y="5760720"/>
-            <a:ext cx="1828800" cy="228600"/>
+            <a:off x="8823960" y="5715000"/>
+            <a:ext cx="1965960" cy="256032"/>
           </a:xfrm>
           <a:prstGeom prst="rect">
             <a:avLst/>
@@ -4537,8 +4732,8 @@
         </p:nvSpPr>
         <p:spPr>
           <a:xfrm>
-            <a:off x="777240" y="2011680"/>
-            <a:ext cx="5394960" cy="4206240"/>
+            <a:off x="777240" y="1847088"/>
+            <a:ext cx="5394960" cy="4526280"/>
           </a:xfrm>
           <a:prstGeom prst="rect">
             <a:avLst/>
@@ -4582,8 +4777,8 @@
         </p:nvSpPr>
         <p:spPr>
           <a:xfrm>
-            <a:off x="6172200" y="2011680"/>
-            <a:ext cx="5257800" cy="4206240"/>
+            <a:off x="6172200" y="1847088"/>
+            <a:ext cx="5257800" cy="4526280"/>
           </a:xfrm>
           <a:prstGeom prst="rect">
             <a:avLst/>
@@ -4627,8 +4822,8 @@
         </p:nvSpPr>
         <p:spPr>
           <a:xfrm>
-            <a:off x="1051560" y="2194560"/>
-            <a:ext cx="4572000" cy="457200"/>
+            <a:off x="1024128" y="2011680"/>
+            <a:ext cx="4846320" cy="457200"/>
           </a:xfrm>
           <a:prstGeom prst="rect">
             <a:avLst/>
@@ -4642,7 +4837,7 @@
           <a:lstStyle/>
           <a:p>
             <a:pPr>
-              <a:defRPr sz="2400" b="1">
+              <a:defRPr sz="2100" b="1">
                 <a:solidFill>
                   <a:srgbClr val="DC3030"/>
                 </a:solidFill>
@@ -4650,7 +4845,7 @@
               </a:defRPr>
             </a:pPr>
             <a:r>
-              <a:t>Strengths &amp; Skills / Previous Projects</a:t>
+              <a:t>Evidence of Current Practice</a:t>
             </a:r>
           </a:p>
         </p:txBody>
@@ -4663,8 +4858,8 @@
         </p:nvSpPr>
         <p:spPr>
           <a:xfrm>
-            <a:off x="1097280" y="2697480"/>
-            <a:ext cx="4754880" cy="3474720"/>
+            <a:off x="1060704" y="2441448"/>
+            <a:ext cx="4937760" cy="3794760"/>
           </a:xfrm>
           <a:prstGeom prst="rect">
             <a:avLst/>
@@ -4678,7 +4873,10 @@
           <a:lstStyle/>
           <a:p>
             <a:pPr>
-              <a:defRPr sz="1800">
+              <a:spcAft>
+                <a:spcPts val="200"/>
+              </a:spcAft>
+              <a:defRPr sz="1450">
                 <a:solidFill>
                   <a:srgbClr val="181818"/>
                 </a:solidFill>
@@ -4686,12 +4884,15 @@
               </a:defRPr>
             </a:pPr>
             <a:r>
-              <a:t>• Photography</a:t>
+              <a:t>• Strengths: photography, video editing, AI creative tools, and software proficiency.</a:t>
             </a:r>
           </a:p>
           <a:p>
             <a:pPr>
-              <a:defRPr sz="1800">
+              <a:spcAft>
+                <a:spcPts val="200"/>
+              </a:spcAft>
+              <a:defRPr sz="1450">
                 <a:solidFill>
                   <a:srgbClr val="181818"/>
                 </a:solidFill>
@@ -4699,12 +4900,15 @@
               </a:defRPr>
             </a:pPr>
             <a:r>
-              <a:t>• Video editing</a:t>
+              <a:t>• Previous MA project: critical video essay on social media culture and affective behaviour.</a:t>
             </a:r>
           </a:p>
           <a:p>
             <a:pPr>
-              <a:defRPr sz="1800">
+              <a:spcAft>
+                <a:spcPts val="200"/>
+              </a:spcAft>
+              <a:defRPr sz="1450">
                 <a:solidFill>
                   <a:srgbClr val="181818"/>
                 </a:solidFill>
@@ -4712,12 +4916,15 @@
               </a:defRPr>
             </a:pPr>
             <a:r>
-              <a:t>• AI creative tools</a:t>
+              <a:t>• Research interests: mental health, social media ecologies, and self-discipline.</a:t>
             </a:r>
           </a:p>
           <a:p>
             <a:pPr>
-              <a:defRPr sz="1800">
+              <a:spcAft>
+                <a:spcPts val="200"/>
+              </a:spcAft>
+              <a:defRPr sz="1450">
                 <a:solidFill>
                   <a:srgbClr val="181818"/>
                 </a:solidFill>
@@ -4725,12 +4932,15 @@
               </a:defRPr>
             </a:pPr>
             <a:r>
-              <a:t>• Software proficiency</a:t>
+              <a:t>• Target audience: Generation Z and millennial social media users.</a:t>
             </a:r>
           </a:p>
           <a:p>
             <a:pPr>
-              <a:defRPr sz="1800">
+              <a:spcAft>
+                <a:spcPts val="200"/>
+              </a:spcAft>
+              <a:defRPr sz="1450">
                 <a:solidFill>
                   <a:srgbClr val="181818"/>
                 </a:solidFill>
@@ -4738,7 +4948,7 @@
               </a:defRPr>
             </a:pPr>
             <a:r>
-              <a:t>• MA project: Critical video work about social media culture</a:t>
+              <a:t>• Existing networks: social media platforms and photography studio communities.</a:t>
             </a:r>
           </a:p>
         </p:txBody>
@@ -4751,8 +4961,8 @@
         </p:nvSpPr>
         <p:spPr>
           <a:xfrm>
-            <a:off x="6446520" y="2194560"/>
-            <a:ext cx="4572000" cy="457200"/>
+            <a:off x="6419088" y="2011680"/>
+            <a:ext cx="4754880" cy="457200"/>
           </a:xfrm>
           <a:prstGeom prst="rect">
             <a:avLst/>
@@ -4766,7 +4976,7 @@
           <a:lstStyle/>
           <a:p>
             <a:pPr>
-              <a:defRPr sz="2400" b="1">
+              <a:defRPr sz="2100" b="1">
                 <a:solidFill>
                   <a:srgbClr val="3263BE"/>
                 </a:solidFill>
@@ -4774,7 +4984,7 @@
               </a:defRPr>
             </a:pPr>
             <a:r>
-              <a:t>Interests / Audience / Networks / Avoid</a:t>
+              <a:t>Critical Reflection &amp; Boundaries</a:t>
             </a:r>
           </a:p>
         </p:txBody>
@@ -4787,8 +4997,8 @@
         </p:nvSpPr>
         <p:spPr>
           <a:xfrm>
-            <a:off x="6492240" y="2697480"/>
-            <a:ext cx="4754880" cy="3474720"/>
+            <a:off x="6473952" y="2441448"/>
+            <a:ext cx="4800600" cy="3794760"/>
           </a:xfrm>
           <a:prstGeom prst="rect">
             <a:avLst/>
@@ -4802,7 +5012,10 @@
           <a:lstStyle/>
           <a:p>
             <a:pPr>
-              <a:defRPr sz="1800">
+              <a:spcAft>
+                <a:spcPts val="200"/>
+              </a:spcAft>
+              <a:defRPr sz="1450">
                 <a:solidFill>
                   <a:srgbClr val="181818"/>
                 </a:solidFill>
@@ -4810,12 +5023,15 @@
               </a:defRPr>
             </a:pPr>
             <a:r>
-              <a:t>• Interests: Mental health, social media, self-discipline</a:t>
+              <a:t>• Current practice is conceptually strong but needs more industry-grounded implementation evidence.</a:t>
             </a:r>
           </a:p>
           <a:p>
             <a:pPr>
-              <a:defRPr sz="1800">
+              <a:spcAft>
+                <a:spcPts val="200"/>
+              </a:spcAft>
+              <a:defRPr sz="1450">
                 <a:solidFill>
                   <a:srgbClr val="181818"/>
                 </a:solidFill>
@@ -4823,12 +5039,15 @@
               </a:defRPr>
             </a:pPr>
             <a:r>
-              <a:t>• Audience: Young social media users (Generation Z, millennials)</a:t>
+              <a:t>• A key development need is translating critical inquiry into commercially viable outputs.</a:t>
             </a:r>
           </a:p>
           <a:p>
             <a:pPr>
-              <a:defRPr sz="1800">
+              <a:spcAft>
+                <a:spcPts val="200"/>
+              </a:spcAft>
+              <a:defRPr sz="1450">
                 <a:solidFill>
                   <a:srgbClr val="181818"/>
                 </a:solidFill>
@@ -4836,12 +5055,15 @@
               </a:defRPr>
             </a:pPr>
             <a:r>
-              <a:t>• Networks: Social media platforms, photography studios</a:t>
+              <a:t>• I intentionally avoid repetitive mechanical commercial production.</a:t>
             </a:r>
           </a:p>
           <a:p>
             <a:pPr>
-              <a:defRPr sz="1800">
+              <a:spcAft>
+                <a:spcPts val="200"/>
+              </a:spcAft>
+              <a:defRPr sz="1450">
                 <a:solidFill>
                   <a:srgbClr val="181818"/>
                 </a:solidFill>
@@ -4849,12 +5071,15 @@
               </a:defRPr>
             </a:pPr>
             <a:r>
-              <a:t>• Avoid repetitive mechanical commercial design</a:t>
+              <a:t>• I also avoid experimental work that is overly abstract and detached from social use value.</a:t>
             </a:r>
           </a:p>
           <a:p>
             <a:pPr>
-              <a:defRPr sz="1800">
+              <a:spcAft>
+                <a:spcPts val="200"/>
+              </a:spcAft>
+              <a:defRPr sz="1450">
                 <a:solidFill>
                   <a:srgbClr val="181818"/>
                 </a:solidFill>
@@ -4862,7 +5087,7 @@
               </a:defRPr>
             </a:pPr>
             <a:r>
-              <a:t>• Avoid overly abstract or ungrounded experimental design</a:t>
+              <a:t>• This boundary-setting helps define a balanced, reflective, and employable design direction.</a:t>
             </a:r>
           </a:p>
         </p:txBody>
@@ -5109,8 +5334,8 @@
         </p:nvSpPr>
         <p:spPr>
           <a:xfrm>
-            <a:off x="731520" y="685800"/>
-            <a:ext cx="10789920" cy="868680"/>
+            <a:off x="731520" y="676656"/>
+            <a:ext cx="10972800" cy="868680"/>
           </a:xfrm>
           <a:prstGeom prst="rect">
             <a:avLst/>
@@ -5124,7 +5349,7 @@
           <a:lstStyle/>
           <a:p>
             <a:pPr>
-              <a:defRPr sz="3800" b="1">
+              <a:defRPr sz="3500" b="1">
                 <a:solidFill>
                   <a:srgbClr val="181818"/>
                 </a:solidFill>
@@ -5145,8 +5370,8 @@
         </p:nvSpPr>
         <p:spPr>
           <a:xfrm>
-            <a:off x="731520" y="1536192"/>
-            <a:ext cx="2926080" cy="82296"/>
+            <a:off x="731520" y="1517904"/>
+            <a:ext cx="3017520" cy="82296"/>
           </a:xfrm>
           <a:prstGeom prst="rect">
             <a:avLst/>
@@ -5188,8 +5413,8 @@
         </p:nvSpPr>
         <p:spPr>
           <a:xfrm>
-            <a:off x="9875520" y="5029200"/>
-            <a:ext cx="1097280" cy="1097280"/>
+            <a:off x="9784080" y="4892040"/>
+            <a:ext cx="1188720" cy="1188720"/>
           </a:xfrm>
           <a:prstGeom prst="ellipse">
             <a:avLst/>
@@ -5231,8 +5456,8 @@
         </p:nvSpPr>
         <p:spPr>
           <a:xfrm>
-            <a:off x="10515600" y="4389120"/>
-            <a:ext cx="1463040" cy="1463040"/>
+            <a:off x="10469880" y="4251960"/>
+            <a:ext cx="1508760" cy="1508760"/>
           </a:xfrm>
           <a:prstGeom prst="ellipse">
             <a:avLst/>
@@ -5274,8 +5499,8 @@
         </p:nvSpPr>
         <p:spPr>
           <a:xfrm>
-            <a:off x="8869680" y="5760720"/>
-            <a:ext cx="1828800" cy="228600"/>
+            <a:off x="8823960" y="5715000"/>
+            <a:ext cx="1965960" cy="256032"/>
           </a:xfrm>
           <a:prstGeom prst="rect">
             <a:avLst/>
@@ -5317,8 +5542,8 @@
         </p:nvSpPr>
         <p:spPr>
           <a:xfrm>
-            <a:off x="868680" y="1920240"/>
-            <a:ext cx="4114800" cy="365760"/>
+            <a:off x="868680" y="1828800"/>
+            <a:ext cx="10424160" cy="384048"/>
           </a:xfrm>
           <a:prstGeom prst="rect">
             <a:avLst/>
@@ -5332,7 +5557,7 @@
           <a:lstStyle/>
           <a:p>
             <a:pPr>
-              <a:defRPr sz="2400" b="1">
+              <a:defRPr sz="2000" b="1">
                 <a:solidFill>
                   <a:srgbClr val="3263BE"/>
                 </a:solidFill>
@@ -5340,7 +5565,7 @@
               </a:defRPr>
             </a:pPr>
             <a:r>
-              <a:t>Long-term goal</a:t>
+              <a:t>Long-term Positioning</a:t>
             </a:r>
           </a:p>
         </p:txBody>
@@ -5353,8 +5578,8 @@
         </p:nvSpPr>
         <p:spPr>
           <a:xfrm>
-            <a:off x="960120" y="2304288"/>
-            <a:ext cx="10332720" cy="502920"/>
+            <a:off x="987552" y="2157984"/>
+            <a:ext cx="10104120" cy="338328"/>
           </a:xfrm>
           <a:prstGeom prst="rect">
             <a:avLst/>
@@ -5369,9 +5594,9 @@
           <a:p>
             <a:pPr>
               <a:spcAft>
-                <a:spcPts val="600"/>
+                <a:spcPts val="200"/>
               </a:spcAft>
-              <a:defRPr sz="2000">
+              <a:defRPr sz="1450">
                 <a:solidFill>
                   <a:srgbClr val="181818"/>
                 </a:solidFill>
@@ -5379,7 +5604,7 @@
               </a:defRPr>
             </a:pPr>
             <a:r>
-              <a:t>• Work in design or AI operation roles in China.</a:t>
+              <a:t>• Pursue design strategy or AI operation roles in China that bridge creativity, technology, and communication.</a:t>
             </a:r>
           </a:p>
         </p:txBody>
@@ -5392,8 +5617,8 @@
         </p:nvSpPr>
         <p:spPr>
           <a:xfrm>
-            <a:off x="868680" y="2898648"/>
-            <a:ext cx="4114800" cy="365760"/>
+            <a:off x="868680" y="2569464"/>
+            <a:ext cx="10424160" cy="384048"/>
           </a:xfrm>
           <a:prstGeom prst="rect">
             <a:avLst/>
@@ -5407,7 +5632,7 @@
           <a:lstStyle/>
           <a:p>
             <a:pPr>
-              <a:defRPr sz="2400" b="1">
+              <a:defRPr sz="2000" b="1">
                 <a:solidFill>
                   <a:srgbClr val="3263BE"/>
                 </a:solidFill>
@@ -5415,7 +5640,7 @@
               </a:defRPr>
             </a:pPr>
             <a:r>
-              <a:t>Skills to develop</a:t>
+              <a:t>Competency Framework</a:t>
             </a:r>
           </a:p>
         </p:txBody>
@@ -5428,8 +5653,8 @@
         </p:nvSpPr>
         <p:spPr>
           <a:xfrm>
-            <a:off x="960120" y="3282696"/>
-            <a:ext cx="10332720" cy="1325880"/>
+            <a:off x="987552" y="2898648"/>
+            <a:ext cx="10104120" cy="905256"/>
           </a:xfrm>
           <a:prstGeom prst="rect">
             <a:avLst/>
@@ -5444,9 +5669,9 @@
           <a:p>
             <a:pPr>
               <a:spcAft>
-                <a:spcPts val="600"/>
+                <a:spcPts val="200"/>
               </a:spcAft>
-              <a:defRPr sz="2000">
+              <a:defRPr sz="1450">
                 <a:solidFill>
                   <a:srgbClr val="181818"/>
                 </a:solidFill>
@@ -5454,15 +5679,15 @@
               </a:defRPr>
             </a:pPr>
             <a:r>
-              <a:t>• Comprehensive use of AI tools</a:t>
+              <a:t>• Technical: comprehensive use of multimodal AI tools across ideation, prototyping, and production.</a:t>
             </a:r>
           </a:p>
           <a:p>
             <a:pPr>
               <a:spcAft>
-                <a:spcPts val="600"/>
+                <a:spcPts val="200"/>
               </a:spcAft>
-              <a:defRPr sz="2000">
+              <a:defRPr sz="1450">
                 <a:solidFill>
                   <a:srgbClr val="181818"/>
                 </a:solidFill>
@@ -5470,15 +5695,15 @@
               </a:defRPr>
             </a:pPr>
             <a:r>
-              <a:t>• Photography &amp; video editing</a:t>
+              <a:t>• Creative: strengthen photography and video editing as narrative and branding instruments.</a:t>
             </a:r>
           </a:p>
           <a:p>
             <a:pPr>
               <a:spcAft>
-                <a:spcPts val="600"/>
+                <a:spcPts val="200"/>
               </a:spcAft>
-              <a:defRPr sz="2000">
+              <a:defRPr sz="1450">
                 <a:solidFill>
                   <a:srgbClr val="181818"/>
                 </a:solidFill>
@@ -5486,7 +5711,7 @@
               </a:defRPr>
             </a:pPr>
             <a:r>
-              <a:t>• Project execution &amp; teamwork</a:t>
+              <a:t>• Professional: improve project execution, cross-functional collaboration, and client communication.</a:t>
             </a:r>
           </a:p>
         </p:txBody>
@@ -5499,8 +5724,8 @@
         </p:nvSpPr>
         <p:spPr>
           <a:xfrm>
-            <a:off x="868680" y="4700016"/>
-            <a:ext cx="4114800" cy="365760"/>
+            <a:off x="868680" y="3877056"/>
+            <a:ext cx="10424160" cy="384048"/>
           </a:xfrm>
           <a:prstGeom prst="rect">
             <a:avLst/>
@@ -5514,7 +5739,7 @@
           <a:lstStyle/>
           <a:p>
             <a:pPr>
-              <a:defRPr sz="2400" b="1">
+              <a:defRPr sz="2000" b="1">
                 <a:solidFill>
                   <a:srgbClr val="3263BE"/>
                 </a:solidFill>
@@ -5522,7 +5747,7 @@
               </a:defRPr>
             </a:pPr>
             <a:r>
-              <a:t>Expected outcomes</a:t>
+              <a:t>Expected Outcomes (Measurable)</a:t>
             </a:r>
           </a:p>
         </p:txBody>
@@ -5535,8 +5760,8 @@
         </p:nvSpPr>
         <p:spPr>
           <a:xfrm>
-            <a:off x="960120" y="5084064"/>
-            <a:ext cx="10332720" cy="1325880"/>
+            <a:off x="987552" y="4206240"/>
+            <a:ext cx="10104120" cy="905256"/>
           </a:xfrm>
           <a:prstGeom prst="rect">
             <a:avLst/>
@@ -5551,9 +5776,9 @@
           <a:p>
             <a:pPr>
               <a:spcAft>
-                <a:spcPts val="600"/>
+                <a:spcPts val="200"/>
               </a:spcAft>
-              <a:defRPr sz="2000">
+              <a:defRPr sz="1450">
                 <a:solidFill>
                   <a:srgbClr val="181818"/>
                 </a:solidFill>
@@ -5561,15 +5786,15 @@
               </a:defRPr>
             </a:pPr>
             <a:r>
-              <a:t>• Professional work experience</a:t>
+              <a:t>• Complete at least 2 externally-oriented projects for portfolio evidence.</a:t>
             </a:r>
           </a:p>
           <a:p>
             <a:pPr>
               <a:spcAft>
-                <a:spcPts val="600"/>
+                <a:spcPts val="200"/>
               </a:spcAft>
-              <a:defRPr sz="2000">
+              <a:defRPr sz="1450">
                 <a:solidFill>
                   <a:srgbClr val="181818"/>
                 </a:solidFill>
@@ -5577,15 +5802,15 @@
               </a:defRPr>
             </a:pPr>
             <a:r>
-              <a:t>• Industry network</a:t>
+              <a:t>• Build an initial professional network across UK and China-related creative industries.</a:t>
             </a:r>
           </a:p>
           <a:p>
             <a:pPr>
               <a:spcAft>
-                <a:spcPts val="600"/>
+                <a:spcPts val="200"/>
               </a:spcAft>
-              <a:defRPr sz="2000">
+              <a:defRPr sz="1450">
                 <a:solidFill>
                   <a:srgbClr val="181818"/>
                 </a:solidFill>
@@ -5593,7 +5818,7 @@
               </a:defRPr>
             </a:pPr>
             <a:r>
-              <a:t>• Stronger portfolio</a:t>
+              <a:t>• Produce a stronger portfolio demonstrating both criticality and implementation capability.</a:t>
             </a:r>
           </a:p>
         </p:txBody>
@@ -5840,8 +6065,8 @@
         </p:nvSpPr>
         <p:spPr>
           <a:xfrm>
-            <a:off x="731520" y="685800"/>
-            <a:ext cx="10789920" cy="868680"/>
+            <a:off x="731520" y="676656"/>
+            <a:ext cx="10972800" cy="868680"/>
           </a:xfrm>
           <a:prstGeom prst="rect">
             <a:avLst/>
@@ -5855,7 +6080,7 @@
           <a:lstStyle/>
           <a:p>
             <a:pPr>
-              <a:defRPr sz="3800" b="1">
+              <a:defRPr sz="3500" b="1">
                 <a:solidFill>
                   <a:srgbClr val="181818"/>
                 </a:solidFill>
@@ -5876,8 +6101,8 @@
         </p:nvSpPr>
         <p:spPr>
           <a:xfrm>
-            <a:off x="731520" y="1536192"/>
-            <a:ext cx="2926080" cy="82296"/>
+            <a:off x="731520" y="1517904"/>
+            <a:ext cx="3017520" cy="82296"/>
           </a:xfrm>
           <a:prstGeom prst="rect">
             <a:avLst/>
@@ -5919,8 +6144,8 @@
         </p:nvSpPr>
         <p:spPr>
           <a:xfrm>
-            <a:off x="9875520" y="5029200"/>
-            <a:ext cx="1097280" cy="1097280"/>
+            <a:off x="9784080" y="4892040"/>
+            <a:ext cx="1188720" cy="1188720"/>
           </a:xfrm>
           <a:prstGeom prst="ellipse">
             <a:avLst/>
@@ -5962,8 +6187,8 @@
         </p:nvSpPr>
         <p:spPr>
           <a:xfrm>
-            <a:off x="10515600" y="4389120"/>
-            <a:ext cx="1463040" cy="1463040"/>
+            <a:off x="10469880" y="4251960"/>
+            <a:ext cx="1508760" cy="1508760"/>
           </a:xfrm>
           <a:prstGeom prst="ellipse">
             <a:avLst/>
@@ -6005,8 +6230,8 @@
         </p:nvSpPr>
         <p:spPr>
           <a:xfrm>
-            <a:off x="8869680" y="5760720"/>
-            <a:ext cx="1828800" cy="228600"/>
+            <a:off x="8823960" y="5715000"/>
+            <a:ext cx="1965960" cy="256032"/>
           </a:xfrm>
           <a:prstGeom prst="rect">
             <a:avLst/>
@@ -6042,14 +6267,104 @@
       </p:sp>
       <p:sp>
         <p:nvSpPr>
-          <p:cNvPr id="12" name="TextBox 11"/>
+          <p:cNvPr id="12" name="Rectangle 11"/>
+          <p:cNvSpPr/>
+          <p:nvPr/>
+        </p:nvSpPr>
+        <p:spPr>
+          <a:xfrm>
+            <a:off x="777240" y="1810512"/>
+            <a:ext cx="7315200" cy="4526280"/>
+          </a:xfrm>
+          <a:prstGeom prst="rect">
+            <a:avLst/>
+          </a:prstGeom>
+          <a:solidFill>
+            <a:srgbClr val="F2F2EE"/>
+          </a:solidFill>
+          <a:ln>
+            <a:solidFill>
+              <a:srgbClr val="181818"/>
+            </a:solidFill>
+          </a:ln>
+        </p:spPr>
+        <p:style>
+          <a:lnRef idx="1">
+            <a:schemeClr val="accent1"/>
+          </a:lnRef>
+          <a:fillRef idx="3">
+            <a:schemeClr val="accent1"/>
+          </a:fillRef>
+          <a:effectRef idx="2">
+            <a:schemeClr val="accent1"/>
+          </a:effectRef>
+          <a:fontRef idx="minor">
+            <a:schemeClr val="lt1"/>
+          </a:fontRef>
+        </p:style>
+        <p:txBody>
+          <a:bodyPr rtlCol="0" anchor="ctr"/>
+          <a:lstStyle/>
+          <a:p>
+            <a:pPr algn="ctr"/>
+          </a:p>
+        </p:txBody>
+      </p:sp>
+      <p:sp>
+        <p:nvSpPr>
+          <p:cNvPr id="13" name="Rectangle 12"/>
+          <p:cNvSpPr/>
+          <p:nvPr/>
+        </p:nvSpPr>
+        <p:spPr>
+          <a:xfrm>
+            <a:off x="8183879" y="1810512"/>
+            <a:ext cx="3291840" cy="4526280"/>
+          </a:xfrm>
+          <a:prstGeom prst="rect">
+            <a:avLst/>
+          </a:prstGeom>
+          <a:solidFill>
+            <a:srgbClr val="F2F2EE"/>
+          </a:solidFill>
+          <a:ln>
+            <a:solidFill>
+              <a:srgbClr val="181818"/>
+            </a:solidFill>
+          </a:ln>
+        </p:spPr>
+        <p:style>
+          <a:lnRef idx="1">
+            <a:schemeClr val="accent1"/>
+          </a:lnRef>
+          <a:fillRef idx="3">
+            <a:schemeClr val="accent1"/>
+          </a:fillRef>
+          <a:effectRef idx="2">
+            <a:schemeClr val="accent1"/>
+          </a:effectRef>
+          <a:fontRef idx="minor">
+            <a:schemeClr val="lt1"/>
+          </a:fontRef>
+        </p:style>
+        <p:txBody>
+          <a:bodyPr rtlCol="0" anchor="ctr"/>
+          <a:lstStyle/>
+          <a:p>
+            <a:pPr algn="ctr"/>
+          </a:p>
+        </p:txBody>
+      </p:sp>
+      <p:sp>
+        <p:nvSpPr>
+          <p:cNvPr id="14" name="TextBox 13"/>
           <p:cNvSpPr txBox="1"/>
           <p:nvPr/>
         </p:nvSpPr>
         <p:spPr>
           <a:xfrm>
-            <a:off x="868680" y="1920240"/>
-            <a:ext cx="4114800" cy="365760"/>
+            <a:off x="1005840" y="2011680"/>
+            <a:ext cx="6949440" cy="4114800"/>
           </a:xfrm>
           <a:prstGeom prst="rect">
             <a:avLst/>
@@ -6063,29 +6378,144 @@
           <a:lstStyle/>
           <a:p>
             <a:pPr>
-              <a:defRPr sz="2400" b="1">
+              <a:defRPr sz="1800" b="1">
+                <a:solidFill>
+                  <a:srgbClr val="DC3030"/>
+                </a:solidFill>
+                <a:latin typeface="Futura"/>
+              </a:defRPr>
+            </a:pPr>
+            <a:r>
+              <a:t>1) Preferred: AI Design Internship (UK)</a:t>
+            </a:r>
+          </a:p>
+          <a:p>
+            <a:pPr>
+              <a:defRPr sz="1400" b="0">
+                <a:solidFill>
+                  <a:srgbClr val="181818"/>
+                </a:solidFill>
+                <a:latin typeface="Arial"/>
+              </a:defRPr>
+            </a:pPr>
+            <a:r>
+              <a:t>   Type: Internship in UK design companies applying AI in commercial creative workflows.</a:t>
+            </a:r>
+          </a:p>
+          <a:p>
+            <a:pPr>
+              <a:defRPr sz="1400" b="0">
+                <a:solidFill>
+                  <a:srgbClr val="181818"/>
+                </a:solidFill>
+                <a:latin typeface="Arial"/>
+              </a:defRPr>
+            </a:pPr>
+            <a:r>
+              <a:t>   Purpose: Learn efficient AI-supported pipeline in real client-facing projects.</a:t>
+            </a:r>
+          </a:p>
+          <a:p>
+            <a:pPr>
+              <a:defRPr sz="1400" b="0">
+                <a:solidFill>
+                  <a:srgbClr val="181818"/>
+                </a:solidFill>
+                <a:latin typeface="Arial"/>
+              </a:defRPr>
+            </a:pPr>
+            <a:r>
+              <a:t>   Rationale: Highest relevance to my planned career pathway in China.</a:t>
+            </a:r>
+          </a:p>
+          <a:p>
+            <a:pPr>
+              <a:defRPr sz="1800" b="1">
+                <a:solidFill>
+                  <a:srgbClr val="DC3030"/>
+                </a:solidFill>
+                <a:latin typeface="Futura"/>
+              </a:defRPr>
+            </a:pPr>
+            <a:r>
+              <a:t>2) UAL / RCA Summer School (real links)</a:t>
+            </a:r>
+          </a:p>
+          <a:p>
+            <a:r>
+              <a:rPr sz="1350">
                 <a:solidFill>
                   <a:srgbClr val="3263BE"/>
                 </a:solidFill>
+                <a:latin typeface="Arial"/>
+                <a:hlinkClick r:id="rId2"/>
+              </a:rPr>
+              <a:t>   UAL Summer School: https://www.arts.ac.uk/summer-shows-events/summer-school</a:t>
+            </a:r>
+          </a:p>
+          <a:p>
+            <a:r>
+              <a:rPr sz="1350">
+                <a:solidFill>
+                  <a:srgbClr val="3263BE"/>
+                </a:solidFill>
+                <a:latin typeface="Arial"/>
+                <a:hlinkClick r:id="rId3"/>
+              </a:rPr>
+              <a:t>   RCA Summer School: https://www.rca.ac.uk/study/summer-courses/</a:t>
+            </a:r>
+          </a:p>
+          <a:p>
+            <a:pPr>
+              <a:defRPr sz="1700" b="1">
+                <a:solidFill>
+                  <a:srgbClr val="DC3030"/>
+                </a:solidFill>
                 <a:latin typeface="Futura"/>
               </a:defRPr>
             </a:pPr>
             <a:r>
-              <a:t>1. Preferred: AI Design Internship (UK)</a:t>
-            </a:r>
-          </a:p>
-        </p:txBody>
-      </p:sp>
-      <p:sp>
-        <p:nvSpPr>
-          <p:cNvPr id="13" name="TextBox 12"/>
+              <a:t>3) Alternative: Creative Studio Internship (London)</a:t>
+            </a:r>
+          </a:p>
+          <a:p>
+            <a:pPr>
+              <a:defRPr sz="1400" b="0">
+                <a:solidFill>
+                  <a:srgbClr val="181818"/>
+                </a:solidFill>
+                <a:latin typeface="Arial"/>
+              </a:defRPr>
+            </a:pPr>
+            <a:r>
+              <a:t>   Focus: 3D printing / architecture-related studio practice.</a:t>
+            </a:r>
+          </a:p>
+          <a:p>
+            <a:pPr>
+              <a:defRPr sz="1400" b="0">
+                <a:solidFill>
+                  <a:srgbClr val="181818"/>
+                </a:solidFill>
+                <a:latin typeface="Arial"/>
+              </a:defRPr>
+            </a:pPr>
+            <a:r>
+              <a:t>   Value: Hands-on making and spatial design experience.</a:t>
+            </a:r>
+          </a:p>
+        </p:txBody>
+      </p:sp>
+      <p:sp>
+        <p:nvSpPr>
+          <p:cNvPr id="15" name="TextBox 14"/>
           <p:cNvSpPr txBox="1"/>
           <p:nvPr/>
         </p:nvSpPr>
         <p:spPr>
           <a:xfrm>
-            <a:off x="960120" y="2304288"/>
-            <a:ext cx="10332720" cy="1325880"/>
+            <a:off x="8412480" y="2011680"/>
+            <a:ext cx="2834640" cy="548640"/>
           </a:xfrm>
           <a:prstGeom prst="rect">
             <a:avLst/>
@@ -6099,64 +6529,29 @@
           <a:lstStyle/>
           <a:p>
             <a:pPr>
-              <a:spcAft>
-                <a:spcPts val="600"/>
-              </a:spcAft>
-              <a:defRPr sz="2000">
-                <a:solidFill>
-                  <a:srgbClr val="181818"/>
-                </a:solidFill>
-                <a:latin typeface="Arial"/>
-              </a:defRPr>
-            </a:pPr>
-            <a:r>
-              <a:t>• Type: Internship at UK design companies using AI for creative work</a:t>
-            </a:r>
-          </a:p>
-          <a:p>
-            <a:pPr>
-              <a:spcAft>
-                <a:spcPts val="600"/>
-              </a:spcAft>
-              <a:defRPr sz="2000">
-                <a:solidFill>
-                  <a:srgbClr val="181818"/>
-                </a:solidFill>
-                <a:latin typeface="Arial"/>
-              </a:defRPr>
-            </a:pPr>
-            <a:r>
-              <a:t>• Purpose: Learn to use AI tools efficiently in real commercial projects</a:t>
-            </a:r>
-          </a:p>
-          <a:p>
-            <a:pPr>
-              <a:spcAft>
-                <a:spcPts val="600"/>
-              </a:spcAft>
-              <a:defRPr sz="2000">
-                <a:solidFill>
-                  <a:srgbClr val="181818"/>
-                </a:solidFill>
-                <a:latin typeface="Arial"/>
-              </a:defRPr>
-            </a:pPr>
-            <a:r>
-              <a:t>• Reason: Best fit for my future career in China</a:t>
-            </a:r>
-          </a:p>
-        </p:txBody>
-      </p:sp>
-      <p:sp>
-        <p:nvSpPr>
-          <p:cNvPr id="14" name="TextBox 13"/>
+              <a:defRPr sz="2000" b="1">
+                <a:solidFill>
+                  <a:srgbClr val="3263BE"/>
+                </a:solidFill>
+                <a:latin typeface="Futura"/>
+              </a:defRPr>
+            </a:pPr>
+            <a:r>
+              <a:t>Selection Criteria</a:t>
+            </a:r>
+          </a:p>
+        </p:txBody>
+      </p:sp>
+      <p:sp>
+        <p:nvSpPr>
+          <p:cNvPr id="16" name="TextBox 15"/>
           <p:cNvSpPr txBox="1"/>
           <p:nvPr/>
         </p:nvSpPr>
         <p:spPr>
           <a:xfrm>
-            <a:off x="868680" y="3721608"/>
-            <a:ext cx="4114800" cy="365760"/>
+            <a:off x="8458200" y="2606040"/>
+            <a:ext cx="2788920" cy="3474720"/>
           </a:xfrm>
           <a:prstGeom prst="rect">
             <a:avLst/>
@@ -6170,104 +6565,46 @@
           <a:lstStyle/>
           <a:p>
             <a:pPr>
-              <a:defRPr sz="2400" b="1">
-                <a:solidFill>
-                  <a:srgbClr val="3263BE"/>
-                </a:solidFill>
-                <a:latin typeface="Futura"/>
-              </a:defRPr>
-            </a:pPr>
-            <a:r>
-              <a:t>2. UAL / RCA Summer School</a:t>
-            </a:r>
-          </a:p>
-        </p:txBody>
-      </p:sp>
-      <p:sp>
-        <p:nvSpPr>
-          <p:cNvPr id="15" name="TextBox 14"/>
-          <p:cNvSpPr txBox="1"/>
-          <p:nvPr/>
-        </p:nvSpPr>
-        <p:spPr>
-          <a:xfrm>
-            <a:off x="960120" y="4105656"/>
-            <a:ext cx="10332720" cy="502920"/>
-          </a:xfrm>
-          <a:prstGeom prst="rect">
-            <a:avLst/>
-          </a:prstGeom>
-          <a:noFill/>
-        </p:spPr>
-        <p:txBody>
-          <a:bodyPr wrap="none">
-            <a:spAutoFit/>
-          </a:bodyPr>
-          <a:lstStyle/>
-          <a:p/>
-        </p:txBody>
-      </p:sp>
-      <p:sp>
-        <p:nvSpPr>
-          <p:cNvPr id="16" name="TextBox 15"/>
-          <p:cNvSpPr txBox="1"/>
-          <p:nvPr/>
-        </p:nvSpPr>
-        <p:spPr>
-          <a:xfrm>
-            <a:off x="1097280" y="4343400"/>
-            <a:ext cx="10058400" cy="1097280"/>
-          </a:xfrm>
-          <a:prstGeom prst="rect">
-            <a:avLst/>
-          </a:prstGeom>
-          <a:noFill/>
-        </p:spPr>
-        <p:txBody>
-          <a:bodyPr wrap="none">
-            <a:spAutoFit/>
-          </a:bodyPr>
-          <a:lstStyle/>
-          <a:p>
-            <a:r>
-              <a:rPr sz="1600">
-                <a:solidFill>
-                  <a:srgbClr val="3263BE"/>
+              <a:defRPr sz="1350" b="0">
+                <a:solidFill>
+                  <a:srgbClr val="181818"/>
                 </a:solidFill>
                 <a:latin typeface="Arial"/>
-                <a:hlinkClick r:id="rId2"/>
-              </a:rPr>
-              <a:t>UAL Summer School: https://www.arts.ac.uk/summer-shows-events/summer-school</a:t>
-            </a:r>
-          </a:p>
-          <a:p>
-            <a:r>
-              <a:rPr sz="1600">
-                <a:solidFill>
-                  <a:srgbClr val="3263BE"/>
+              </a:defRPr>
+            </a:pPr>
+            <a:r>
+              <a:t>• Career relevance</a:t>
+            </a:r>
+          </a:p>
+          <a:p>
+            <a:pPr>
+              <a:defRPr sz="1350" b="0">
+                <a:solidFill>
+                  <a:srgbClr val="181818"/>
                 </a:solidFill>
                 <a:latin typeface="Arial"/>
-                <a:hlinkClick r:id="rId3"/>
-              </a:rPr>
-              <a:t>RCA Summer School: https://www.rca.ac.uk/study/summer-courses/</a:t>
+              </a:defRPr>
+            </a:pPr>
+            <a:r>
+              <a:t>• Learning depth</a:t>
             </a:r>
           </a:p>
           <a:p>
             <a:pPr>
-              <a:defRPr sz="2000" b="1">
-                <a:solidFill>
-                  <a:srgbClr val="DC3030"/>
-                </a:solidFill>
-                <a:latin typeface="Futura"/>
-              </a:defRPr>
-            </a:pPr>
-            <a:r>
-              <a:t>3. Alternative: Creative Studio Internship (London)</a:t>
+              <a:defRPr sz="1350" b="0">
+                <a:solidFill>
+                  <a:srgbClr val="181818"/>
+                </a:solidFill>
+                <a:latin typeface="Arial"/>
+              </a:defRPr>
+            </a:pPr>
+            <a:r>
+              <a:t>• Industry exposure</a:t>
             </a:r>
           </a:p>
           <a:p>
             <a:pPr>
-              <a:defRPr sz="1700">
+              <a:defRPr sz="1350" b="0">
                 <a:solidFill>
                   <a:srgbClr val="181818"/>
                 </a:solidFill>
@@ -6275,12 +6612,12 @@
               </a:defRPr>
             </a:pPr>
             <a:r>
-              <a:t>• 3D printing / architectural design studio</a:t>
+              <a:t>• Visa/time feasibility</a:t>
             </a:r>
           </a:p>
           <a:p>
             <a:pPr>
-              <a:defRPr sz="1700">
+              <a:defRPr sz="1350" b="0">
                 <a:solidFill>
                   <a:srgbClr val="181818"/>
                 </a:solidFill>
@@ -6288,7 +6625,82 @@
               </a:defRPr>
             </a:pPr>
             <a:r>
-              <a:t>• Gain hands-on making &amp; spatial design experience</a:t>
+              <a:t>• Portfolio value</a:t>
+            </a:r>
+          </a:p>
+          <a:p>
+            <a:pPr>
+              <a:defRPr sz="1350" b="0">
+                <a:solidFill>
+                  <a:srgbClr val="181818"/>
+                </a:solidFill>
+                <a:latin typeface="Arial"/>
+              </a:defRPr>
+            </a:pPr>
+            <a:r>
+              <a:t>• Network potential</a:t>
+            </a:r>
+          </a:p>
+          <a:p>
+            <a:pPr>
+              <a:defRPr sz="1350" b="0">
+                <a:solidFill>
+                  <a:srgbClr val="181818"/>
+                </a:solidFill>
+                <a:latin typeface="Arial"/>
+              </a:defRPr>
+            </a:pPr>
+          </a:p>
+          <a:p>
+            <a:pPr>
+              <a:defRPr sz="1350" b="1">
+                <a:solidFill>
+                  <a:srgbClr val="181818"/>
+                </a:solidFill>
+                <a:latin typeface="Arial"/>
+              </a:defRPr>
+            </a:pPr>
+            <a:r>
+              <a:t>Preferred ranking:</a:t>
+            </a:r>
+          </a:p>
+          <a:p>
+            <a:pPr>
+              <a:defRPr sz="1350" b="0">
+                <a:solidFill>
+                  <a:srgbClr val="181818"/>
+                </a:solidFill>
+                <a:latin typeface="Arial"/>
+              </a:defRPr>
+            </a:pPr>
+            <a:r>
+              <a:t>1. AI internship</a:t>
+            </a:r>
+          </a:p>
+          <a:p>
+            <a:pPr>
+              <a:defRPr sz="1350" b="0">
+                <a:solidFill>
+                  <a:srgbClr val="181818"/>
+                </a:solidFill>
+                <a:latin typeface="Arial"/>
+              </a:defRPr>
+            </a:pPr>
+            <a:r>
+              <a:t>2. Summer school</a:t>
+            </a:r>
+          </a:p>
+          <a:p>
+            <a:pPr>
+              <a:defRPr sz="1350" b="0">
+                <a:solidFill>
+                  <a:srgbClr val="181818"/>
+                </a:solidFill>
+                <a:latin typeface="Arial"/>
+              </a:defRPr>
+            </a:pPr>
+            <a:r>
+              <a:t>3. Creative studio</a:t>
             </a:r>
           </a:p>
         </p:txBody>
@@ -6535,8 +6947,8 @@
         </p:nvSpPr>
         <p:spPr>
           <a:xfrm>
-            <a:off x="731520" y="685800"/>
-            <a:ext cx="10789920" cy="868680"/>
+            <a:off x="731520" y="676656"/>
+            <a:ext cx="10972800" cy="868680"/>
           </a:xfrm>
           <a:prstGeom prst="rect">
             <a:avLst/>
@@ -6550,7 +6962,7 @@
           <a:lstStyle/>
           <a:p>
             <a:pPr>
-              <a:defRPr sz="3800" b="1">
+              <a:defRPr sz="3500" b="1">
                 <a:solidFill>
                   <a:srgbClr val="181818"/>
                 </a:solidFill>
@@ -6571,8 +6983,8 @@
         </p:nvSpPr>
         <p:spPr>
           <a:xfrm>
-            <a:off x="731520" y="1536192"/>
-            <a:ext cx="2926080" cy="82296"/>
+            <a:off x="731520" y="1517904"/>
+            <a:ext cx="3017520" cy="82296"/>
           </a:xfrm>
           <a:prstGeom prst="rect">
             <a:avLst/>
@@ -6614,7 +7026,7 @@
         </p:nvSpPr>
         <p:spPr>
           <a:xfrm>
-            <a:off x="914400" y="3291840"/>
+            <a:off x="914400" y="3246120"/>
             <a:ext cx="10058400" cy="73152"/>
           </a:xfrm>
           <a:prstGeom prst="rect">
@@ -6657,8 +7069,8 @@
         </p:nvSpPr>
         <p:spPr>
           <a:xfrm>
-            <a:off x="2103120" y="2971800"/>
-            <a:ext cx="640080" cy="640080"/>
+            <a:off x="2057400" y="2926080"/>
+            <a:ext cx="685800" cy="685800"/>
           </a:xfrm>
           <a:prstGeom prst="ellipse">
             <a:avLst/>
@@ -6700,8 +7112,8 @@
         </p:nvSpPr>
         <p:spPr>
           <a:xfrm>
-            <a:off x="6858000" y="2971800"/>
-            <a:ext cx="640080" cy="640080"/>
+            <a:off x="6812280" y="2926080"/>
+            <a:ext cx="685800" cy="685800"/>
           </a:xfrm>
           <a:prstGeom prst="ellipse">
             <a:avLst/>
@@ -6743,8 +7155,8 @@
         </p:nvSpPr>
         <p:spPr>
           <a:xfrm>
-            <a:off x="1097280" y="1783080"/>
-            <a:ext cx="4023360" cy="1463040"/>
+            <a:off x="1005840" y="1600200"/>
+            <a:ext cx="4663440" cy="1554480"/>
           </a:xfrm>
           <a:prstGeom prst="rect">
             <a:avLst/>
@@ -6758,7 +7170,7 @@
           <a:lstStyle/>
           <a:p>
             <a:pPr>
-              <a:defRPr sz="3000" b="1">
+              <a:defRPr sz="2500" b="1">
                 <a:solidFill>
                   <a:srgbClr val="DC3030"/>
                 </a:solidFill>
@@ -6766,47 +7178,47 @@
               </a:defRPr>
             </a:pPr>
             <a:r>
-              <a:t>April – June</a:t>
+              <a:t>April – June: Preparation Phase</a:t>
             </a:r>
           </a:p>
           <a:p>
             <a:pPr>
-              <a:defRPr sz="1600">
+              <a:defRPr sz="1350">
                 <a:latin typeface="Arial"/>
               </a:defRPr>
             </a:pPr>
             <a:r>
-              <a:t>• Complete university coursework</a:t>
+              <a:t>• Complete university coursework and define project focus</a:t>
             </a:r>
           </a:p>
           <a:p>
             <a:pPr>
-              <a:defRPr sz="1600">
+              <a:defRPr sz="1350">
                 <a:latin typeface="Arial"/>
               </a:defRPr>
             </a:pPr>
             <a:r>
-              <a:t>• Prepare CV &amp; portfolio</a:t>
+              <a:t>• Update CV and portfolio with targeted case studies</a:t>
             </a:r>
           </a:p>
           <a:p>
             <a:pPr>
-              <a:defRPr sz="1600">
+              <a:defRPr sz="1350">
                 <a:latin typeface="Arial"/>
               </a:defRPr>
             </a:pPr>
             <a:r>
-              <a:t>• Apply for internships &amp; summer schools</a:t>
+              <a:t>• Submit internship/summer-school applications and attend interviews</a:t>
             </a:r>
           </a:p>
           <a:p>
             <a:pPr>
-              <a:defRPr sz="1600">
+              <a:defRPr sz="1350">
                 <a:latin typeface="Arial"/>
               </a:defRPr>
             </a:pPr>
             <a:r>
-              <a:t>• Attend interviews</a:t>
+              <a:t>• Build reflective research log and application tracker</a:t>
             </a:r>
           </a:p>
         </p:txBody>
@@ -6819,8 +7231,8 @@
         </p:nvSpPr>
         <p:spPr>
           <a:xfrm>
-            <a:off x="5852160" y="3611880"/>
-            <a:ext cx="4754880" cy="1463040"/>
+            <a:off x="5715000" y="3566160"/>
+            <a:ext cx="5394960" cy="1874519"/>
           </a:xfrm>
           <a:prstGeom prst="rect">
             <a:avLst/>
@@ -6834,7 +7246,7 @@
           <a:lstStyle/>
           <a:p>
             <a:pPr>
-              <a:defRPr sz="3000" b="1">
+              <a:defRPr sz="2500" b="1">
                 <a:solidFill>
                   <a:srgbClr val="3263BE"/>
                 </a:solidFill>
@@ -6842,27 +7254,37 @@
               </a:defRPr>
             </a:pPr>
             <a:r>
-              <a:t>July – September</a:t>
+              <a:t>July – September: Implementation Phase</a:t>
             </a:r>
           </a:p>
           <a:p>
             <a:pPr>
-              <a:defRPr sz="1600">
+              <a:defRPr sz="1350">
                 <a:latin typeface="Arial"/>
               </a:defRPr>
             </a:pPr>
             <a:r>
-              <a:t>• Start internship / summer school</a:t>
+              <a:t>• Start internship / summer school and document workflow learning</a:t>
             </a:r>
           </a:p>
           <a:p>
             <a:pPr>
-              <a:defRPr sz="1600">
+              <a:defRPr sz="1350">
                 <a:latin typeface="Arial"/>
               </a:defRPr>
             </a:pPr>
             <a:r>
-              <a:t>• Continue part-time photography &amp; editing work</a:t>
+              <a:t>• Continue part-time photography and editing for applied practice</a:t>
+            </a:r>
+          </a:p>
+          <a:p>
+            <a:pPr>
+              <a:defRPr sz="1350">
+                <a:latin typeface="Arial"/>
+              </a:defRPr>
+            </a:pPr>
+            <a:r>
+              <a:t>• Conduct mid-point self-evaluation and final portfolio consolidation</a:t>
             </a:r>
           </a:p>
         </p:txBody>
@@ -7109,8 +7531,8 @@
         </p:nvSpPr>
         <p:spPr>
           <a:xfrm>
-            <a:off x="731520" y="685800"/>
-            <a:ext cx="10789920" cy="868680"/>
+            <a:off x="731520" y="676656"/>
+            <a:ext cx="10972800" cy="868680"/>
           </a:xfrm>
           <a:prstGeom prst="rect">
             <a:avLst/>
@@ -7124,7 +7546,7 @@
           <a:lstStyle/>
           <a:p>
             <a:pPr>
-              <a:defRPr sz="3800" b="1">
+              <a:defRPr sz="3500" b="1">
                 <a:solidFill>
                   <a:srgbClr val="181818"/>
                 </a:solidFill>
@@ -7145,8 +7567,8 @@
         </p:nvSpPr>
         <p:spPr>
           <a:xfrm>
-            <a:off x="731520" y="1536192"/>
-            <a:ext cx="2926080" cy="82296"/>
+            <a:off x="731520" y="1517904"/>
+            <a:ext cx="3017520" cy="82296"/>
           </a:xfrm>
           <a:prstGeom prst="rect">
             <a:avLst/>
@@ -7188,8 +7610,8 @@
         </p:nvSpPr>
         <p:spPr>
           <a:xfrm>
-            <a:off x="9875520" y="5029200"/>
-            <a:ext cx="1097280" cy="1097280"/>
+            <a:off x="9784080" y="4892040"/>
+            <a:ext cx="1188720" cy="1188720"/>
           </a:xfrm>
           <a:prstGeom prst="ellipse">
             <a:avLst/>
@@ -7231,8 +7653,8 @@
         </p:nvSpPr>
         <p:spPr>
           <a:xfrm>
-            <a:off x="10515600" y="4389120"/>
-            <a:ext cx="1463040" cy="1463040"/>
+            <a:off x="10469880" y="4251960"/>
+            <a:ext cx="1508760" cy="1508760"/>
           </a:xfrm>
           <a:prstGeom prst="ellipse">
             <a:avLst/>
@@ -7274,8 +7696,8 @@
         </p:nvSpPr>
         <p:spPr>
           <a:xfrm>
-            <a:off x="8869680" y="5760720"/>
-            <a:ext cx="1828800" cy="228600"/>
+            <a:off x="8823960" y="5715000"/>
+            <a:ext cx="1965960" cy="256032"/>
           </a:xfrm>
           <a:prstGeom prst="rect">
             <a:avLst/>
@@ -7317,8 +7739,8 @@
         </p:nvSpPr>
         <p:spPr>
           <a:xfrm>
-            <a:off x="868680" y="1920240"/>
-            <a:ext cx="4114800" cy="365760"/>
+            <a:off x="868680" y="1783080"/>
+            <a:ext cx="10424160" cy="384048"/>
           </a:xfrm>
           <a:prstGeom prst="rect">
             <a:avLst/>
@@ -7332,7 +7754,7 @@
           <a:lstStyle/>
           <a:p>
             <a:pPr>
-              <a:defRPr sz="2400" b="1">
+              <a:defRPr sz="1900" b="1">
                 <a:solidFill>
                   <a:srgbClr val="3263BE"/>
                 </a:solidFill>
@@ -7340,7 +7762,7 @@
               </a:defRPr>
             </a:pPr>
             <a:r>
-              <a:t>Feasibility</a:t>
+              <a:t>Operational Feasibility</a:t>
             </a:r>
           </a:p>
         </p:txBody>
@@ -7353,8 +7775,8 @@
         </p:nvSpPr>
         <p:spPr>
           <a:xfrm>
-            <a:off x="960120" y="2304288"/>
-            <a:ext cx="10332720" cy="502920"/>
+            <a:off x="987552" y="2112264"/>
+            <a:ext cx="10104120" cy="585215"/>
           </a:xfrm>
           <a:prstGeom prst="rect">
             <a:avLst/>
@@ -7369,9 +7791,9 @@
           <a:p>
             <a:pPr>
               <a:spcAft>
-                <a:spcPts val="600"/>
+                <a:spcPts val="200"/>
               </a:spcAft>
-              <a:defRPr sz="2000">
+              <a:defRPr sz="1400">
                 <a:solidFill>
                   <a:srgbClr val="181818"/>
                 </a:solidFill>
@@ -7379,7 +7801,23 @@
               </a:defRPr>
             </a:pPr>
             <a:r>
-              <a:t>• Location: London (feasible for international student visa)</a:t>
+              <a:t>• Location: London is feasible within current international student visa conditions.</a:t>
+            </a:r>
+          </a:p>
+          <a:p>
+            <a:pPr>
+              <a:spcAft>
+                <a:spcPts val="200"/>
+              </a:spcAft>
+              <a:defRPr sz="1400">
+                <a:solidFill>
+                  <a:srgbClr val="181818"/>
+                </a:solidFill>
+                <a:latin typeface="Arial"/>
+              </a:defRPr>
+            </a:pPr>
+            <a:r>
+              <a:t>• Resources: portfolio revision plan, application email templates, and AI studio shortlist are prepared.</a:t>
             </a:r>
           </a:p>
         </p:txBody>
@@ -7392,8 +7830,8 @@
         </p:nvSpPr>
         <p:spPr>
           <a:xfrm>
-            <a:off x="868680" y="2898648"/>
-            <a:ext cx="4114800" cy="365760"/>
+            <a:off x="868680" y="2770632"/>
+            <a:ext cx="10424160" cy="384048"/>
           </a:xfrm>
           <a:prstGeom prst="rect">
             <a:avLst/>
@@ -7407,7 +7845,7 @@
           <a:lstStyle/>
           <a:p>
             <a:pPr>
-              <a:defRPr sz="2400" b="1">
+              <a:defRPr sz="1900" b="1">
                 <a:solidFill>
                   <a:srgbClr val="3263BE"/>
                 </a:solidFill>
@@ -7415,7 +7853,7 @@
               </a:defRPr>
             </a:pPr>
             <a:r>
-              <a:t>Preparation</a:t>
+              <a:t>Risk Management</a:t>
             </a:r>
           </a:p>
         </p:txBody>
@@ -7428,8 +7866,8 @@
         </p:nvSpPr>
         <p:spPr>
           <a:xfrm>
-            <a:off x="960120" y="3282696"/>
-            <a:ext cx="10332720" cy="1325880"/>
+            <a:off x="987552" y="3099815"/>
+            <a:ext cx="10104120" cy="585215"/>
           </a:xfrm>
           <a:prstGeom prst="rect">
             <a:avLst/>
@@ -7444,9 +7882,9 @@
           <a:p>
             <a:pPr>
               <a:spcAft>
-                <a:spcPts val="600"/>
+                <a:spcPts val="200"/>
               </a:spcAft>
-              <a:defRPr sz="2000">
+              <a:defRPr sz="1400">
                 <a:solidFill>
                   <a:srgbClr val="181818"/>
                 </a:solidFill>
@@ -7454,15 +7892,15 @@
               </a:defRPr>
             </a:pPr>
             <a:r>
-              <a:t>• Update portfolio</a:t>
+              <a:t>• Risk: internship competition and uncertain acceptance timelines.</a:t>
             </a:r>
           </a:p>
           <a:p>
             <a:pPr>
               <a:spcAft>
-                <a:spcPts val="600"/>
+                <a:spcPts val="200"/>
               </a:spcAft>
-              <a:defRPr sz="2000">
+              <a:defRPr sz="1400">
                 <a:solidFill>
                   <a:srgbClr val="181818"/>
                 </a:solidFill>
@@ -7470,23 +7908,7 @@
               </a:defRPr>
             </a:pPr>
             <a:r>
-              <a:t>• Write application emails</a:t>
-            </a:r>
-          </a:p>
-          <a:p>
-            <a:pPr>
-              <a:spcAft>
-                <a:spcPts val="600"/>
-              </a:spcAft>
-              <a:defRPr sz="2000">
-                <a:solidFill>
-                  <a:srgbClr val="181818"/>
-                </a:solidFill>
-                <a:latin typeface="Arial"/>
-              </a:defRPr>
-            </a:pPr>
-            <a:r>
-              <a:t>• Research AI studios</a:t>
+              <a:t>• Mitigation: parallel applications (internship + summer school + studio option) and phased decision points.</a:t>
             </a:r>
           </a:p>
         </p:txBody>
@@ -7499,8 +7921,8 @@
         </p:nvSpPr>
         <p:spPr>
           <a:xfrm>
-            <a:off x="868680" y="4700016"/>
-            <a:ext cx="4114800" cy="365760"/>
+            <a:off x="868680" y="3758183"/>
+            <a:ext cx="10424160" cy="384048"/>
           </a:xfrm>
           <a:prstGeom prst="rect">
             <a:avLst/>
@@ -7514,7 +7936,7 @@
           <a:lstStyle/>
           <a:p>
             <a:pPr>
-              <a:defRPr sz="2400" b="1">
+              <a:defRPr sz="1900" b="1">
                 <a:solidFill>
                   <a:srgbClr val="3263BE"/>
                 </a:solidFill>
@@ -7522,7 +7944,7 @@
               </a:defRPr>
             </a:pPr>
             <a:r>
-              <a:t>Flexibility</a:t>
+              <a:t>Ethics &amp; Professional Standards</a:t>
             </a:r>
           </a:p>
         </p:txBody>
@@ -7535,8 +7957,8 @@
         </p:nvSpPr>
         <p:spPr>
           <a:xfrm>
-            <a:off x="960120" y="5084064"/>
-            <a:ext cx="10332720" cy="502920"/>
+            <a:off x="987552" y="4087368"/>
+            <a:ext cx="10104120" cy="585215"/>
           </a:xfrm>
           <a:prstGeom prst="rect">
             <a:avLst/>
@@ -7551,9 +7973,9 @@
           <a:p>
             <a:pPr>
               <a:spcAft>
-                <a:spcPts val="600"/>
+                <a:spcPts val="200"/>
               </a:spcAft>
-              <a:defRPr sz="2000">
+              <a:defRPr sz="1400">
                 <a:solidFill>
                   <a:srgbClr val="181818"/>
                 </a:solidFill>
@@ -7561,7 +7983,98 @@
               </a:defRPr>
             </a:pPr>
             <a:r>
-              <a:t>• Combine internship/study with part-time work</a:t>
+              <a:t>• Address AI-related concerns on authorship, bias, and data provenance in project documentation.</a:t>
+            </a:r>
+          </a:p>
+          <a:p>
+            <a:pPr>
+              <a:spcAft>
+                <a:spcPts val="200"/>
+              </a:spcAft>
+              <a:defRPr sz="1400">
+                <a:solidFill>
+                  <a:srgbClr val="181818"/>
+                </a:solidFill>
+                <a:latin typeface="Arial"/>
+              </a:defRPr>
+            </a:pPr>
+            <a:r>
+              <a:t>• Maintain reflective records to evidence critical decision-making, not only technical output.</a:t>
+            </a:r>
+          </a:p>
+        </p:txBody>
+      </p:sp>
+      <p:sp>
+        <p:nvSpPr>
+          <p:cNvPr id="18" name="TextBox 17"/>
+          <p:cNvSpPr txBox="1"/>
+          <p:nvPr/>
+        </p:nvSpPr>
+        <p:spPr>
+          <a:xfrm>
+            <a:off x="868680" y="4745736"/>
+            <a:ext cx="10424160" cy="384048"/>
+          </a:xfrm>
+          <a:prstGeom prst="rect">
+            <a:avLst/>
+          </a:prstGeom>
+          <a:noFill/>
+        </p:spPr>
+        <p:txBody>
+          <a:bodyPr wrap="none">
+            <a:spAutoFit/>
+          </a:bodyPr>
+          <a:lstStyle/>
+          <a:p>
+            <a:pPr>
+              <a:defRPr sz="1900" b="1">
+                <a:solidFill>
+                  <a:srgbClr val="3263BE"/>
+                </a:solidFill>
+                <a:latin typeface="Futura"/>
+              </a:defRPr>
+            </a:pPr>
+            <a:r>
+              <a:t>Flexibility</a:t>
+            </a:r>
+          </a:p>
+        </p:txBody>
+      </p:sp>
+      <p:sp>
+        <p:nvSpPr>
+          <p:cNvPr id="19" name="TextBox 18"/>
+          <p:cNvSpPr txBox="1"/>
+          <p:nvPr/>
+        </p:nvSpPr>
+        <p:spPr>
+          <a:xfrm>
+            <a:off x="987552" y="5074920"/>
+            <a:ext cx="10104120" cy="320040"/>
+          </a:xfrm>
+          <a:prstGeom prst="rect">
+            <a:avLst/>
+          </a:prstGeom>
+          <a:noFill/>
+        </p:spPr>
+        <p:txBody>
+          <a:bodyPr wrap="none">
+            <a:spAutoFit/>
+          </a:bodyPr>
+          <a:lstStyle/>
+          <a:p>
+            <a:pPr>
+              <a:spcAft>
+                <a:spcPts val="200"/>
+              </a:spcAft>
+              <a:defRPr sz="1400">
+                <a:solidFill>
+                  <a:srgbClr val="181818"/>
+                </a:solidFill>
+                <a:latin typeface="Arial"/>
+              </a:defRPr>
+            </a:pPr>
+            <a:r>
+              <a:t>• Internship/study activities can be combined with part-time creative work to maintain continuity.</a:t>
             </a:r>
           </a:p>
         </p:txBody>
@@ -7808,8 +8321,8 @@
         </p:nvSpPr>
         <p:spPr>
           <a:xfrm>
-            <a:off x="731520" y="685800"/>
-            <a:ext cx="10789920" cy="868680"/>
+            <a:off x="731520" y="676656"/>
+            <a:ext cx="10972800" cy="868680"/>
           </a:xfrm>
           <a:prstGeom prst="rect">
             <a:avLst/>
@@ -7823,7 +8336,7 @@
           <a:lstStyle/>
           <a:p>
             <a:pPr>
-              <a:defRPr sz="3800" b="1">
+              <a:defRPr sz="3500" b="1">
                 <a:solidFill>
                   <a:srgbClr val="181818"/>
                 </a:solidFill>
@@ -7844,8 +8357,8 @@
         </p:nvSpPr>
         <p:spPr>
           <a:xfrm>
-            <a:off x="731520" y="1536192"/>
-            <a:ext cx="2926080" cy="82296"/>
+            <a:off x="731520" y="1517904"/>
+            <a:ext cx="3017520" cy="82296"/>
           </a:xfrm>
           <a:prstGeom prst="rect">
             <a:avLst/>
@@ -7887,8 +8400,8 @@
         </p:nvSpPr>
         <p:spPr>
           <a:xfrm>
-            <a:off x="914400" y="1828800"/>
-            <a:ext cx="10332720" cy="3291840"/>
+            <a:off x="868680" y="1783080"/>
+            <a:ext cx="10424160" cy="4526280"/>
           </a:xfrm>
           <a:prstGeom prst="rect">
             <a:avLst/>
@@ -7932,8 +8445,8 @@
         </p:nvSpPr>
         <p:spPr>
           <a:xfrm>
-            <a:off x="1280160" y="2286000"/>
-            <a:ext cx="9692640" cy="2468880"/>
+            <a:off x="1143000" y="2148840"/>
+            <a:ext cx="9875520" cy="3840480"/>
           </a:xfrm>
           <a:prstGeom prst="rect">
             <a:avLst/>
@@ -7941,13 +8454,16 @@
           <a:noFill/>
         </p:spPr>
         <p:txBody>
-          <a:bodyPr wrap="square">
+          <a:bodyPr wrap="none">
             <a:spAutoFit/>
           </a:bodyPr>
           <a:lstStyle/>
           <a:p>
-            <a:pPr algn="l">
-              <a:defRPr sz="2800" b="0">
+            <a:pPr>
+              <a:spcAft>
+                <a:spcPts val="1000"/>
+              </a:spcAft>
+              <a:defRPr sz="2000" b="1">
                 <a:solidFill>
                   <a:srgbClr val="181818"/>
                 </a:solidFill>
@@ -7955,7 +8471,55 @@
               </a:defRPr>
             </a:pPr>
             <a:r>
-              <a:t>This Extended Study will help me build practical AI design skills, clarify my career path, and gain industry experience that directly supports my future work in China. It is a process of exploration to find my creative direction and professional identity.</a:t>
+              <a:t>This Extended Study is framed as a practice-led inquiry into AI-enabled design development.</a:t>
+            </a:r>
+          </a:p>
+          <a:p>
+            <a:pPr>
+              <a:spcAft>
+                <a:spcPts val="1000"/>
+              </a:spcAft>
+              <a:defRPr sz="1700" b="0">
+                <a:solidFill>
+                  <a:srgbClr val="181818"/>
+                </a:solidFill>
+                <a:latin typeface="Arial"/>
+              </a:defRPr>
+            </a:pPr>
+            <a:r>
+              <a:t>It links critical reflection with professional experimentation to clarify my creative direction and career identity.</a:t>
+            </a:r>
+          </a:p>
+          <a:p>
+            <a:pPr>
+              <a:spcAft>
+                <a:spcPts val="1000"/>
+              </a:spcAft>
+              <a:defRPr sz="1700" b="0">
+                <a:solidFill>
+                  <a:srgbClr val="181818"/>
+                </a:solidFill>
+                <a:latin typeface="Arial"/>
+              </a:defRPr>
+            </a:pPr>
+            <a:r>
+              <a:t>By combining internships, summer programmes, and independent practice, the project will produce measurable outcomes: improved technical fluency, stronger portfolio evidence, and expanded industry networks.</a:t>
+            </a:r>
+          </a:p>
+          <a:p>
+            <a:pPr>
+              <a:spcAft>
+                <a:spcPts val="1000"/>
+              </a:spcAft>
+              <a:defRPr sz="1700" b="0">
+                <a:solidFill>
+                  <a:srgbClr val="181818"/>
+                </a:solidFill>
+                <a:latin typeface="Arial"/>
+              </a:defRPr>
+            </a:pPr>
+            <a:r>
+              <a:t>Ultimately, the study supports a transition toward future-facing design or AI operation roles in China with both conceptual depth and practical readiness.</a:t>
             </a:r>
           </a:p>
         </p:txBody>
@@ -7968,8 +8532,8 @@
         </p:nvSpPr>
         <p:spPr>
           <a:xfrm>
-            <a:off x="502920" y="5440680"/>
-            <a:ext cx="2011680" cy="320040"/>
+            <a:off x="502920" y="5486400"/>
+            <a:ext cx="2057400" cy="301752"/>
           </a:xfrm>
           <a:prstGeom prst="rect">
             <a:avLst/>
@@ -8011,8 +8575,8 @@
         </p:nvSpPr>
         <p:spPr>
           <a:xfrm>
-            <a:off x="10744200" y="5349240"/>
-            <a:ext cx="868680" cy="868680"/>
+            <a:off x="10698480" y="5321808"/>
+            <a:ext cx="896112" cy="896112"/>
           </a:xfrm>
           <a:prstGeom prst="ellipse">
             <a:avLst/>
@@ -8054,8 +8618,8 @@
         </p:nvSpPr>
         <p:spPr>
           <a:xfrm>
-            <a:off x="9829800" y="5760720"/>
-            <a:ext cx="1143000" cy="274320"/>
+            <a:off x="9784080" y="5715000"/>
+            <a:ext cx="1188720" cy="283464"/>
           </a:xfrm>
           <a:prstGeom prst="rect">
             <a:avLst/>

</xml_diff>

<commit_message>
Convert deck to English and enforce text auto-fit
Co-authored-by: maotianyi12138-eng <maotianyi12138-eng@users.noreply.github.com>
</commit_message>
<xml_diff>
--- a/Finding_Direction_Through_Exploration_Bauhaus.pptx
+++ b/Finding_Direction_Through_Exploration_Bauhaus.pptx
@@ -3139,7 +3139,9 @@
           </a:fontRef>
         </p:style>
         <p:txBody>
-          <a:bodyPr rtlCol="0" anchor="ctr"/>
+          <a:bodyPr rtlCol="0" anchor="ctr" wrap="square">
+            <a:normAutofit/>
+          </a:bodyPr>
           <a:lstStyle/>
           <a:p>
             <a:pPr algn="ctr"/>
@@ -3182,7 +3184,9 @@
           </a:fontRef>
         </p:style>
         <p:txBody>
-          <a:bodyPr rtlCol="0" anchor="ctr"/>
+          <a:bodyPr rtlCol="0" anchor="ctr" wrap="square">
+            <a:normAutofit/>
+          </a:bodyPr>
           <a:lstStyle/>
           <a:p>
             <a:pPr algn="ctr"/>
@@ -3225,7 +3229,9 @@
           </a:fontRef>
         </p:style>
         <p:txBody>
-          <a:bodyPr rtlCol="0" anchor="ctr"/>
+          <a:bodyPr rtlCol="0" anchor="ctr" wrap="square">
+            <a:normAutofit/>
+          </a:bodyPr>
           <a:lstStyle/>
           <a:p>
             <a:pPr algn="ctr"/>
@@ -3268,7 +3274,9 @@
           </a:fontRef>
         </p:style>
         <p:txBody>
-          <a:bodyPr rtlCol="0" anchor="ctr"/>
+          <a:bodyPr rtlCol="0" anchor="ctr" wrap="square">
+            <a:normAutofit/>
+          </a:bodyPr>
           <a:lstStyle/>
           <a:p>
             <a:pPr algn="ctr"/>
@@ -3292,8 +3300,8 @@
           <a:noFill/>
         </p:spPr>
         <p:txBody>
-          <a:bodyPr wrap="none">
-            <a:spAutoFit/>
+          <a:bodyPr wrap="square">
+            <a:normAutofit/>
           </a:bodyPr>
           <a:lstStyle/>
           <a:p>
@@ -3347,7 +3355,9 @@
           </a:fontRef>
         </p:style>
         <p:txBody>
-          <a:bodyPr rtlCol="0" anchor="ctr"/>
+          <a:bodyPr rtlCol="0" anchor="ctr" wrap="square">
+            <a:normAutofit/>
+          </a:bodyPr>
           <a:lstStyle/>
           <a:p>
             <a:pPr algn="ctr"/>
@@ -3390,7 +3400,9 @@
           </a:fontRef>
         </p:style>
         <p:txBody>
-          <a:bodyPr rtlCol="0" anchor="ctr"/>
+          <a:bodyPr rtlCol="0" anchor="ctr" wrap="square">
+            <a:normAutofit/>
+          </a:bodyPr>
           <a:lstStyle/>
           <a:p>
             <a:pPr algn="ctr"/>
@@ -3433,7 +3445,9 @@
           </a:fontRef>
         </p:style>
         <p:txBody>
-          <a:bodyPr rtlCol="0" anchor="ctr"/>
+          <a:bodyPr rtlCol="0" anchor="ctr" wrap="square">
+            <a:normAutofit/>
+          </a:bodyPr>
           <a:lstStyle/>
           <a:p>
             <a:pPr algn="ctr"/>
@@ -3457,8 +3471,8 @@
           <a:noFill/>
         </p:spPr>
         <p:txBody>
-          <a:bodyPr wrap="none">
-            <a:spAutoFit/>
+          <a:bodyPr wrap="square">
+            <a:normAutofit/>
           </a:bodyPr>
           <a:lstStyle/>
           <a:p>
@@ -3506,8 +3520,8 @@
           <a:noFill/>
         </p:spPr>
         <p:txBody>
-          <a:bodyPr wrap="none">
-            <a:spAutoFit/>
+          <a:bodyPr wrap="square">
+            <a:normAutofit/>
           </a:bodyPr>
           <a:lstStyle/>
           <a:p>
@@ -3613,7 +3627,9 @@
           </a:fontRef>
         </p:style>
         <p:txBody>
-          <a:bodyPr rtlCol="0" anchor="ctr"/>
+          <a:bodyPr rtlCol="0" anchor="ctr" wrap="square">
+            <a:normAutofit/>
+          </a:bodyPr>
           <a:lstStyle/>
           <a:p>
             <a:pPr algn="ctr"/>
@@ -3656,7 +3672,9 @@
           </a:fontRef>
         </p:style>
         <p:txBody>
-          <a:bodyPr rtlCol="0" anchor="ctr"/>
+          <a:bodyPr rtlCol="0" anchor="ctr" wrap="square">
+            <a:normAutofit/>
+          </a:bodyPr>
           <a:lstStyle/>
           <a:p>
             <a:pPr algn="ctr"/>
@@ -3699,7 +3717,9 @@
           </a:fontRef>
         </p:style>
         <p:txBody>
-          <a:bodyPr rtlCol="0" anchor="ctr"/>
+          <a:bodyPr rtlCol="0" anchor="ctr" wrap="square">
+            <a:normAutofit/>
+          </a:bodyPr>
           <a:lstStyle/>
           <a:p>
             <a:pPr algn="ctr"/>
@@ -3742,7 +3762,9 @@
           </a:fontRef>
         </p:style>
         <p:txBody>
-          <a:bodyPr rtlCol="0" anchor="ctr"/>
+          <a:bodyPr rtlCol="0" anchor="ctr" wrap="square">
+            <a:normAutofit/>
+          </a:bodyPr>
           <a:lstStyle/>
           <a:p>
             <a:pPr algn="ctr"/>
@@ -3766,8 +3788,8 @@
           <a:noFill/>
         </p:spPr>
         <p:txBody>
-          <a:bodyPr wrap="none">
-            <a:spAutoFit/>
+          <a:bodyPr wrap="square">
+            <a:normAutofit/>
           </a:bodyPr>
           <a:lstStyle/>
           <a:p>
@@ -3802,13 +3824,13 @@
           <a:noFill/>
         </p:spPr>
         <p:txBody>
-          <a:bodyPr wrap="none">
-            <a:spAutoFit/>
+          <a:bodyPr wrap="square">
+            <a:normAutofit/>
           </a:bodyPr>
           <a:lstStyle/>
           <a:p>
             <a:pPr>
-              <a:defRPr sz="3500" b="1">
+              <a:defRPr sz="3300" b="1">
                 <a:solidFill>
                   <a:srgbClr val="181818"/>
                 </a:solidFill>
@@ -3816,7 +3838,7 @@
               </a:defRPr>
             </a:pPr>
             <a:r>
-              <a:t>Page 2 Introduction 引言</a:t>
+              <a:t>Page 2: Introduction</a:t>
             </a:r>
           </a:p>
         </p:txBody>
@@ -3857,7 +3879,9 @@
           </a:fontRef>
         </p:style>
         <p:txBody>
-          <a:bodyPr rtlCol="0" anchor="ctr"/>
+          <a:bodyPr rtlCol="0" anchor="ctr" wrap="square">
+            <a:normAutofit/>
+          </a:bodyPr>
           <a:lstStyle/>
           <a:p>
             <a:pPr algn="ctr"/>
@@ -3900,7 +3924,9 @@
           </a:fontRef>
         </p:style>
         <p:txBody>
-          <a:bodyPr rtlCol="0" anchor="ctr"/>
+          <a:bodyPr rtlCol="0" anchor="ctr" wrap="square">
+            <a:normAutofit/>
+          </a:bodyPr>
           <a:lstStyle/>
           <a:p>
             <a:pPr algn="ctr"/>
@@ -3943,7 +3969,9 @@
           </a:fontRef>
         </p:style>
         <p:txBody>
-          <a:bodyPr rtlCol="0" anchor="ctr"/>
+          <a:bodyPr rtlCol="0" anchor="ctr" wrap="square">
+            <a:normAutofit/>
+          </a:bodyPr>
           <a:lstStyle/>
           <a:p>
             <a:pPr algn="ctr"/>
@@ -3986,7 +4014,9 @@
           </a:fontRef>
         </p:style>
         <p:txBody>
-          <a:bodyPr rtlCol="0" anchor="ctr"/>
+          <a:bodyPr rtlCol="0" anchor="ctr" wrap="square">
+            <a:normAutofit/>
+          </a:bodyPr>
           <a:lstStyle/>
           <a:p>
             <a:pPr algn="ctr"/>
@@ -4010,8 +4040,8 @@
           <a:noFill/>
         </p:spPr>
         <p:txBody>
-          <a:bodyPr wrap="none">
-            <a:spAutoFit/>
+          <a:bodyPr wrap="square">
+            <a:normAutofit/>
           </a:bodyPr>
           <a:lstStyle/>
           <a:p>
@@ -4046,8 +4076,8 @@
           <a:noFill/>
         </p:spPr>
         <p:txBody>
-          <a:bodyPr wrap="none">
-            <a:spAutoFit/>
+          <a:bodyPr wrap="square">
+            <a:normAutofit/>
           </a:bodyPr>
           <a:lstStyle/>
           <a:p>
@@ -4079,7 +4109,7 @@
               </a:defRPr>
             </a:pPr>
             <a:r>
-              <a:t>• This study adopts a practice-led perspective to connect tool competence with professional identity formation.</a:t>
+              <a:t>• This study uses a practice-led approach to connect technical capability with professional identity.</a:t>
             </a:r>
           </a:p>
         </p:txBody>
@@ -4101,8 +4131,8 @@
           <a:noFill/>
         </p:spPr>
         <p:txBody>
-          <a:bodyPr wrap="none">
-            <a:spAutoFit/>
+          <a:bodyPr wrap="square">
+            <a:normAutofit/>
           </a:bodyPr>
           <a:lstStyle/>
           <a:p>
@@ -4137,8 +4167,8 @@
           <a:noFill/>
         </p:spPr>
         <p:txBody>
-          <a:bodyPr wrap="none">
-            <a:spAutoFit/>
+          <a:bodyPr wrap="square">
+            <a:normAutofit/>
           </a:bodyPr>
           <a:lstStyle/>
           <a:p>
@@ -4170,7 +4200,7 @@
               </a:defRPr>
             </a:pPr>
             <a:r>
-              <a:t>• Identify a sustainable professional direction that aligns with my values and strengths.</a:t>
+              <a:t>• Identify a sustainable professional direction aligned with my values and strengths.</a:t>
             </a:r>
           </a:p>
           <a:p>
@@ -4208,8 +4238,8 @@
           <a:noFill/>
         </p:spPr>
         <p:txBody>
-          <a:bodyPr wrap="none">
-            <a:spAutoFit/>
+          <a:bodyPr wrap="square">
+            <a:normAutofit/>
           </a:bodyPr>
           <a:lstStyle/>
           <a:p>
@@ -4244,8 +4274,8 @@
           <a:noFill/>
         </p:spPr>
         <p:txBody>
-          <a:bodyPr wrap="none">
-            <a:spAutoFit/>
+          <a:bodyPr wrap="square">
+            <a:normAutofit/>
           </a:bodyPr>
           <a:lstStyle/>
           <a:p>
@@ -4261,7 +4291,7 @@
               </a:defRPr>
             </a:pPr>
             <a:r>
-              <a:t>• How can AI be integrated into end-to-end creative workflow while preserving design authorship?</a:t>
+              <a:t>• How can AI support end-to-end design workflow while preserving authorship and intent?</a:t>
             </a:r>
           </a:p>
           <a:p>
@@ -4277,7 +4307,7 @@
               </a:defRPr>
             </a:pPr>
             <a:r>
-              <a:t>• Which pathway best connects my current skills with long-term opportunities in China?</a:t>
+              <a:t>• Which pathway best bridges my current skill set and career opportunities in China?</a:t>
             </a:r>
           </a:p>
         </p:txBody>
@@ -4344,7 +4374,9 @@
           </a:fontRef>
         </p:style>
         <p:txBody>
-          <a:bodyPr rtlCol="0" anchor="ctr"/>
+          <a:bodyPr rtlCol="0" anchor="ctr" wrap="square">
+            <a:normAutofit/>
+          </a:bodyPr>
           <a:lstStyle/>
           <a:p>
             <a:pPr algn="ctr"/>
@@ -4387,7 +4419,9 @@
           </a:fontRef>
         </p:style>
         <p:txBody>
-          <a:bodyPr rtlCol="0" anchor="ctr"/>
+          <a:bodyPr rtlCol="0" anchor="ctr" wrap="square">
+            <a:normAutofit/>
+          </a:bodyPr>
           <a:lstStyle/>
           <a:p>
             <a:pPr algn="ctr"/>
@@ -4430,7 +4464,9 @@
           </a:fontRef>
         </p:style>
         <p:txBody>
-          <a:bodyPr rtlCol="0" anchor="ctr"/>
+          <a:bodyPr rtlCol="0" anchor="ctr" wrap="square">
+            <a:normAutofit/>
+          </a:bodyPr>
           <a:lstStyle/>
           <a:p>
             <a:pPr algn="ctr"/>
@@ -4473,7 +4509,9 @@
           </a:fontRef>
         </p:style>
         <p:txBody>
-          <a:bodyPr rtlCol="0" anchor="ctr"/>
+          <a:bodyPr rtlCol="0" anchor="ctr" wrap="square">
+            <a:normAutofit/>
+          </a:bodyPr>
           <a:lstStyle/>
           <a:p>
             <a:pPr algn="ctr"/>
@@ -4497,8 +4535,8 @@
           <a:noFill/>
         </p:spPr>
         <p:txBody>
-          <a:bodyPr wrap="none">
-            <a:spAutoFit/>
+          <a:bodyPr wrap="square">
+            <a:normAutofit/>
           </a:bodyPr>
           <a:lstStyle/>
           <a:p>
@@ -4533,13 +4571,13 @@
           <a:noFill/>
         </p:spPr>
         <p:txBody>
-          <a:bodyPr wrap="none">
-            <a:spAutoFit/>
+          <a:bodyPr wrap="square">
+            <a:normAutofit/>
           </a:bodyPr>
           <a:lstStyle/>
           <a:p>
             <a:pPr>
-              <a:defRPr sz="3500" b="1">
+              <a:defRPr sz="3300" b="1">
                 <a:solidFill>
                   <a:srgbClr val="181818"/>
                 </a:solidFill>
@@ -4547,7 +4585,7 @@
               </a:defRPr>
             </a:pPr>
             <a:r>
-              <a:t>Page 3 Past Practice 过往实践</a:t>
+              <a:t>Page 3: Past Practice</a:t>
             </a:r>
           </a:p>
         </p:txBody>
@@ -4588,7 +4626,9 @@
           </a:fontRef>
         </p:style>
         <p:txBody>
-          <a:bodyPr rtlCol="0" anchor="ctr"/>
+          <a:bodyPr rtlCol="0" anchor="ctr" wrap="square">
+            <a:normAutofit/>
+          </a:bodyPr>
           <a:lstStyle/>
           <a:p>
             <a:pPr algn="ctr"/>
@@ -4631,7 +4671,9 @@
           </a:fontRef>
         </p:style>
         <p:txBody>
-          <a:bodyPr rtlCol="0" anchor="ctr"/>
+          <a:bodyPr rtlCol="0" anchor="ctr" wrap="square">
+            <a:normAutofit/>
+          </a:bodyPr>
           <a:lstStyle/>
           <a:p>
             <a:pPr algn="ctr"/>
@@ -4674,7 +4716,9 @@
           </a:fontRef>
         </p:style>
         <p:txBody>
-          <a:bodyPr rtlCol="0" anchor="ctr"/>
+          <a:bodyPr rtlCol="0" anchor="ctr" wrap="square">
+            <a:normAutofit/>
+          </a:bodyPr>
           <a:lstStyle/>
           <a:p>
             <a:pPr algn="ctr"/>
@@ -4717,7 +4761,9 @@
           </a:fontRef>
         </p:style>
         <p:txBody>
-          <a:bodyPr rtlCol="0" anchor="ctr"/>
+          <a:bodyPr rtlCol="0" anchor="ctr" wrap="square">
+            <a:normAutofit/>
+          </a:bodyPr>
           <a:lstStyle/>
           <a:p>
             <a:pPr algn="ctr"/>
@@ -4762,7 +4808,9 @@
           </a:fontRef>
         </p:style>
         <p:txBody>
-          <a:bodyPr rtlCol="0" anchor="ctr"/>
+          <a:bodyPr rtlCol="0" anchor="ctr" wrap="square">
+            <a:normAutofit/>
+          </a:bodyPr>
           <a:lstStyle/>
           <a:p>
             <a:pPr algn="ctr"/>
@@ -4807,7 +4855,9 @@
           </a:fontRef>
         </p:style>
         <p:txBody>
-          <a:bodyPr rtlCol="0" anchor="ctr"/>
+          <a:bodyPr rtlCol="0" anchor="ctr" wrap="square">
+            <a:normAutofit/>
+          </a:bodyPr>
           <a:lstStyle/>
           <a:p>
             <a:pPr algn="ctr"/>
@@ -4831,8 +4881,8 @@
           <a:noFill/>
         </p:spPr>
         <p:txBody>
-          <a:bodyPr wrap="none">
-            <a:spAutoFit/>
+          <a:bodyPr wrap="square">
+            <a:normAutofit/>
           </a:bodyPr>
           <a:lstStyle/>
           <a:p>
@@ -4867,8 +4917,8 @@
           <a:noFill/>
         </p:spPr>
         <p:txBody>
-          <a:bodyPr wrap="none">
-            <a:spAutoFit/>
+          <a:bodyPr wrap="square">
+            <a:normAutofit/>
           </a:bodyPr>
           <a:lstStyle/>
           <a:p>
@@ -4876,7 +4926,7 @@
               <a:spcAft>
                 <a:spcPts val="200"/>
               </a:spcAft>
-              <a:defRPr sz="1450">
+              <a:defRPr sz="1420">
                 <a:solidFill>
                   <a:srgbClr val="181818"/>
                 </a:solidFill>
@@ -4892,7 +4942,7 @@
               <a:spcAft>
                 <a:spcPts val="200"/>
               </a:spcAft>
-              <a:defRPr sz="1450">
+              <a:defRPr sz="1420">
                 <a:solidFill>
                   <a:srgbClr val="181818"/>
                 </a:solidFill>
@@ -4900,7 +4950,7 @@
               </a:defRPr>
             </a:pPr>
             <a:r>
-              <a:t>• Previous MA project: critical video essay on social media culture and affective behaviour.</a:t>
+              <a:t>• Previous MA project: critical video essay on social media culture and affective behavior.</a:t>
             </a:r>
           </a:p>
           <a:p>
@@ -4908,7 +4958,7 @@
               <a:spcAft>
                 <a:spcPts val="200"/>
               </a:spcAft>
-              <a:defRPr sz="1450">
+              <a:defRPr sz="1420">
                 <a:solidFill>
                   <a:srgbClr val="181818"/>
                 </a:solidFill>
@@ -4924,7 +4974,7 @@
               <a:spcAft>
                 <a:spcPts val="200"/>
               </a:spcAft>
-              <a:defRPr sz="1450">
+              <a:defRPr sz="1420">
                 <a:solidFill>
                   <a:srgbClr val="181818"/>
                 </a:solidFill>
@@ -4940,7 +4990,7 @@
               <a:spcAft>
                 <a:spcPts val="200"/>
               </a:spcAft>
-              <a:defRPr sz="1450">
+              <a:defRPr sz="1420">
                 <a:solidFill>
                   <a:srgbClr val="181818"/>
                 </a:solidFill>
@@ -4970,8 +5020,8 @@
           <a:noFill/>
         </p:spPr>
         <p:txBody>
-          <a:bodyPr wrap="none">
-            <a:spAutoFit/>
+          <a:bodyPr wrap="square">
+            <a:normAutofit/>
           </a:bodyPr>
           <a:lstStyle/>
           <a:p>
@@ -4984,7 +5034,7 @@
               </a:defRPr>
             </a:pPr>
             <a:r>
-              <a:t>Critical Reflection &amp; Boundaries</a:t>
+              <a:t>Critical Reflection and Boundaries</a:t>
             </a:r>
           </a:p>
         </p:txBody>
@@ -5006,8 +5056,8 @@
           <a:noFill/>
         </p:spPr>
         <p:txBody>
-          <a:bodyPr wrap="none">
-            <a:spAutoFit/>
+          <a:bodyPr wrap="square">
+            <a:normAutofit/>
           </a:bodyPr>
           <a:lstStyle/>
           <a:p>
@@ -5015,7 +5065,7 @@
               <a:spcAft>
                 <a:spcPts val="200"/>
               </a:spcAft>
-              <a:defRPr sz="1450">
+              <a:defRPr sz="1420">
                 <a:solidFill>
                   <a:srgbClr val="181818"/>
                 </a:solidFill>
@@ -5031,7 +5081,7 @@
               <a:spcAft>
                 <a:spcPts val="200"/>
               </a:spcAft>
-              <a:defRPr sz="1450">
+              <a:defRPr sz="1420">
                 <a:solidFill>
                   <a:srgbClr val="181818"/>
                 </a:solidFill>
@@ -5039,7 +5089,7 @@
               </a:defRPr>
             </a:pPr>
             <a:r>
-              <a:t>• A key development need is translating critical inquiry into commercially viable outputs.</a:t>
+              <a:t>• A key need is translating critical inquiry into commercially viable design outcomes.</a:t>
             </a:r>
           </a:p>
           <a:p>
@@ -5047,7 +5097,7 @@
               <a:spcAft>
                 <a:spcPts val="200"/>
               </a:spcAft>
-              <a:defRPr sz="1450">
+              <a:defRPr sz="1420">
                 <a:solidFill>
                   <a:srgbClr val="181818"/>
                 </a:solidFill>
@@ -5055,7 +5105,7 @@
               </a:defRPr>
             </a:pPr>
             <a:r>
-              <a:t>• I intentionally avoid repetitive mechanical commercial production.</a:t>
+              <a:t>• I intentionally avoid repetitive and purely mechanical commercial production.</a:t>
             </a:r>
           </a:p>
           <a:p>
@@ -5063,7 +5113,7 @@
               <a:spcAft>
                 <a:spcPts val="200"/>
               </a:spcAft>
-              <a:defRPr sz="1450">
+              <a:defRPr sz="1420">
                 <a:solidFill>
                   <a:srgbClr val="181818"/>
                 </a:solidFill>
@@ -5071,7 +5121,7 @@
               </a:defRPr>
             </a:pPr>
             <a:r>
-              <a:t>• I also avoid experimental work that is overly abstract and detached from social use value.</a:t>
+              <a:t>• I also avoid experimental work that is abstract and detached from social use value.</a:t>
             </a:r>
           </a:p>
           <a:p>
@@ -5079,7 +5129,7 @@
               <a:spcAft>
                 <a:spcPts val="200"/>
               </a:spcAft>
-              <a:defRPr sz="1450">
+              <a:defRPr sz="1420">
                 <a:solidFill>
                   <a:srgbClr val="181818"/>
                 </a:solidFill>
@@ -5087,7 +5137,7 @@
               </a:defRPr>
             </a:pPr>
             <a:r>
-              <a:t>• This boundary-setting helps define a balanced, reflective, and employable design direction.</a:t>
+              <a:t>• These boundaries define a balanced, reflective, and employable direction.</a:t>
             </a:r>
           </a:p>
         </p:txBody>
@@ -5154,7 +5204,9 @@
           </a:fontRef>
         </p:style>
         <p:txBody>
-          <a:bodyPr rtlCol="0" anchor="ctr"/>
+          <a:bodyPr rtlCol="0" anchor="ctr" wrap="square">
+            <a:normAutofit/>
+          </a:bodyPr>
           <a:lstStyle/>
           <a:p>
             <a:pPr algn="ctr"/>
@@ -5197,7 +5249,9 @@
           </a:fontRef>
         </p:style>
         <p:txBody>
-          <a:bodyPr rtlCol="0" anchor="ctr"/>
+          <a:bodyPr rtlCol="0" anchor="ctr" wrap="square">
+            <a:normAutofit/>
+          </a:bodyPr>
           <a:lstStyle/>
           <a:p>
             <a:pPr algn="ctr"/>
@@ -5240,7 +5294,9 @@
           </a:fontRef>
         </p:style>
         <p:txBody>
-          <a:bodyPr rtlCol="0" anchor="ctr"/>
+          <a:bodyPr rtlCol="0" anchor="ctr" wrap="square">
+            <a:normAutofit/>
+          </a:bodyPr>
           <a:lstStyle/>
           <a:p>
             <a:pPr algn="ctr"/>
@@ -5283,7 +5339,9 @@
           </a:fontRef>
         </p:style>
         <p:txBody>
-          <a:bodyPr rtlCol="0" anchor="ctr"/>
+          <a:bodyPr rtlCol="0" anchor="ctr" wrap="square">
+            <a:normAutofit/>
+          </a:bodyPr>
           <a:lstStyle/>
           <a:p>
             <a:pPr algn="ctr"/>
@@ -5307,8 +5365,8 @@
           <a:noFill/>
         </p:spPr>
         <p:txBody>
-          <a:bodyPr wrap="none">
-            <a:spAutoFit/>
+          <a:bodyPr wrap="square">
+            <a:normAutofit/>
           </a:bodyPr>
           <a:lstStyle/>
           <a:p>
@@ -5343,13 +5401,13 @@
           <a:noFill/>
         </p:spPr>
         <p:txBody>
-          <a:bodyPr wrap="none">
-            <a:spAutoFit/>
+          <a:bodyPr wrap="square">
+            <a:normAutofit/>
           </a:bodyPr>
           <a:lstStyle/>
           <a:p>
             <a:pPr>
-              <a:defRPr sz="3500" b="1">
+              <a:defRPr sz="3300" b="1">
                 <a:solidFill>
                   <a:srgbClr val="181818"/>
                 </a:solidFill>
@@ -5357,7 +5415,7 @@
               </a:defRPr>
             </a:pPr>
             <a:r>
-              <a:t>Page 4 Future Goals 未来目标</a:t>
+              <a:t>Page 4: Future Goals</a:t>
             </a:r>
           </a:p>
         </p:txBody>
@@ -5398,7 +5456,9 @@
           </a:fontRef>
         </p:style>
         <p:txBody>
-          <a:bodyPr rtlCol="0" anchor="ctr"/>
+          <a:bodyPr rtlCol="0" anchor="ctr" wrap="square">
+            <a:normAutofit/>
+          </a:bodyPr>
           <a:lstStyle/>
           <a:p>
             <a:pPr algn="ctr"/>
@@ -5441,7 +5501,9 @@
           </a:fontRef>
         </p:style>
         <p:txBody>
-          <a:bodyPr rtlCol="0" anchor="ctr"/>
+          <a:bodyPr rtlCol="0" anchor="ctr" wrap="square">
+            <a:normAutofit/>
+          </a:bodyPr>
           <a:lstStyle/>
           <a:p>
             <a:pPr algn="ctr"/>
@@ -5484,7 +5546,9 @@
           </a:fontRef>
         </p:style>
         <p:txBody>
-          <a:bodyPr rtlCol="0" anchor="ctr"/>
+          <a:bodyPr rtlCol="0" anchor="ctr" wrap="square">
+            <a:normAutofit/>
+          </a:bodyPr>
           <a:lstStyle/>
           <a:p>
             <a:pPr algn="ctr"/>
@@ -5527,7 +5591,9 @@
           </a:fontRef>
         </p:style>
         <p:txBody>
-          <a:bodyPr rtlCol="0" anchor="ctr"/>
+          <a:bodyPr rtlCol="0" anchor="ctr" wrap="square">
+            <a:normAutofit/>
+          </a:bodyPr>
           <a:lstStyle/>
           <a:p>
             <a:pPr algn="ctr"/>
@@ -5551,8 +5617,8 @@
           <a:noFill/>
         </p:spPr>
         <p:txBody>
-          <a:bodyPr wrap="none">
-            <a:spAutoFit/>
+          <a:bodyPr wrap="square">
+            <a:normAutofit/>
           </a:bodyPr>
           <a:lstStyle/>
           <a:p>
@@ -5565,7 +5631,7 @@
               </a:defRPr>
             </a:pPr>
             <a:r>
-              <a:t>Long-term Positioning</a:t>
+              <a:t>Long-Term Positioning</a:t>
             </a:r>
           </a:p>
         </p:txBody>
@@ -5587,8 +5653,8 @@
           <a:noFill/>
         </p:spPr>
         <p:txBody>
-          <a:bodyPr wrap="none">
-            <a:spAutoFit/>
+          <a:bodyPr wrap="square">
+            <a:normAutofit/>
           </a:bodyPr>
           <a:lstStyle/>
           <a:p>
@@ -5604,7 +5670,7 @@
               </a:defRPr>
             </a:pPr>
             <a:r>
-              <a:t>• Pursue design strategy or AI operation roles in China that bridge creativity, technology, and communication.</a:t>
+              <a:t>• Pursue design strategy or AI operation roles in China that connect creativity, technology, and communication.</a:t>
             </a:r>
           </a:p>
         </p:txBody>
@@ -5626,8 +5692,8 @@
           <a:noFill/>
         </p:spPr>
         <p:txBody>
-          <a:bodyPr wrap="none">
-            <a:spAutoFit/>
+          <a:bodyPr wrap="square">
+            <a:normAutofit/>
           </a:bodyPr>
           <a:lstStyle/>
           <a:p>
@@ -5662,8 +5728,8 @@
           <a:noFill/>
         </p:spPr>
         <p:txBody>
-          <a:bodyPr wrap="none">
-            <a:spAutoFit/>
+          <a:bodyPr wrap="square">
+            <a:normAutofit/>
           </a:bodyPr>
           <a:lstStyle/>
           <a:p>
@@ -5679,7 +5745,7 @@
               </a:defRPr>
             </a:pPr>
             <a:r>
-              <a:t>• Technical: comprehensive use of multimodal AI tools across ideation, prototyping, and production.</a:t>
+              <a:t>• Technical: use multimodal AI tools across ideation, prototyping, and production.</a:t>
             </a:r>
           </a:p>
           <a:p>
@@ -5695,7 +5761,7 @@
               </a:defRPr>
             </a:pPr>
             <a:r>
-              <a:t>• Creative: strengthen photography and video editing as narrative and branding instruments.</a:t>
+              <a:t>• Creative: strengthen photography and video editing as narrative and branding methods.</a:t>
             </a:r>
           </a:p>
           <a:p>
@@ -5711,7 +5777,7 @@
               </a:defRPr>
             </a:pPr>
             <a:r>
-              <a:t>• Professional: improve project execution, cross-functional collaboration, and client communication.</a:t>
+              <a:t>• Professional: improve project execution, collaboration, and client communication.</a:t>
             </a:r>
           </a:p>
         </p:txBody>
@@ -5733,8 +5799,8 @@
           <a:noFill/>
         </p:spPr>
         <p:txBody>
-          <a:bodyPr wrap="none">
-            <a:spAutoFit/>
+          <a:bodyPr wrap="square">
+            <a:normAutofit/>
           </a:bodyPr>
           <a:lstStyle/>
           <a:p>
@@ -5747,7 +5813,7 @@
               </a:defRPr>
             </a:pPr>
             <a:r>
-              <a:t>Expected Outcomes (Measurable)</a:t>
+              <a:t>Expected Outcomes</a:t>
             </a:r>
           </a:p>
         </p:txBody>
@@ -5769,8 +5835,8 @@
           <a:noFill/>
         </p:spPr>
         <p:txBody>
-          <a:bodyPr wrap="none">
-            <a:spAutoFit/>
+          <a:bodyPr wrap="square">
+            <a:normAutofit/>
           </a:bodyPr>
           <a:lstStyle/>
           <a:p>
@@ -5786,7 +5852,7 @@
               </a:defRPr>
             </a:pPr>
             <a:r>
-              <a:t>• Complete at least 2 externally-oriented projects for portfolio evidence.</a:t>
+              <a:t>• Complete at least two externally oriented projects for portfolio evidence.</a:t>
             </a:r>
           </a:p>
           <a:p>
@@ -5802,7 +5868,7 @@
               </a:defRPr>
             </a:pPr>
             <a:r>
-              <a:t>• Build an initial professional network across UK and China-related creative industries.</a:t>
+              <a:t>• Build an initial professional network across UK and China-related creative sectors.</a:t>
             </a:r>
           </a:p>
           <a:p>
@@ -5818,7 +5884,7 @@
               </a:defRPr>
             </a:pPr>
             <a:r>
-              <a:t>• Produce a stronger portfolio demonstrating both criticality and implementation capability.</a:t>
+              <a:t>• Deliver a portfolio that demonstrates both critical thinking and implementation ability.</a:t>
             </a:r>
           </a:p>
         </p:txBody>
@@ -5885,7 +5951,9 @@
           </a:fontRef>
         </p:style>
         <p:txBody>
-          <a:bodyPr rtlCol="0" anchor="ctr"/>
+          <a:bodyPr rtlCol="0" anchor="ctr" wrap="square">
+            <a:normAutofit/>
+          </a:bodyPr>
           <a:lstStyle/>
           <a:p>
             <a:pPr algn="ctr"/>
@@ -5928,7 +5996,9 @@
           </a:fontRef>
         </p:style>
         <p:txBody>
-          <a:bodyPr rtlCol="0" anchor="ctr"/>
+          <a:bodyPr rtlCol="0" anchor="ctr" wrap="square">
+            <a:normAutofit/>
+          </a:bodyPr>
           <a:lstStyle/>
           <a:p>
             <a:pPr algn="ctr"/>
@@ -5971,7 +6041,9 @@
           </a:fontRef>
         </p:style>
         <p:txBody>
-          <a:bodyPr rtlCol="0" anchor="ctr"/>
+          <a:bodyPr rtlCol="0" anchor="ctr" wrap="square">
+            <a:normAutofit/>
+          </a:bodyPr>
           <a:lstStyle/>
           <a:p>
             <a:pPr algn="ctr"/>
@@ -6014,7 +6086,9 @@
           </a:fontRef>
         </p:style>
         <p:txBody>
-          <a:bodyPr rtlCol="0" anchor="ctr"/>
+          <a:bodyPr rtlCol="0" anchor="ctr" wrap="square">
+            <a:normAutofit/>
+          </a:bodyPr>
           <a:lstStyle/>
           <a:p>
             <a:pPr algn="ctr"/>
@@ -6038,8 +6112,8 @@
           <a:noFill/>
         </p:spPr>
         <p:txBody>
-          <a:bodyPr wrap="none">
-            <a:spAutoFit/>
+          <a:bodyPr wrap="square">
+            <a:normAutofit/>
           </a:bodyPr>
           <a:lstStyle/>
           <a:p>
@@ -6074,13 +6148,13 @@
           <a:noFill/>
         </p:spPr>
         <p:txBody>
-          <a:bodyPr wrap="none">
-            <a:spAutoFit/>
+          <a:bodyPr wrap="square">
+            <a:normAutofit/>
           </a:bodyPr>
           <a:lstStyle/>
           <a:p>
             <a:pPr>
-              <a:defRPr sz="3500" b="1">
+              <a:defRPr sz="3300" b="1">
                 <a:solidFill>
                   <a:srgbClr val="181818"/>
                 </a:solidFill>
@@ -6088,7 +6162,7 @@
               </a:defRPr>
             </a:pPr>
             <a:r>
-              <a:t>Page 5 Activity Options 实践选项（含真实夏校链接）</a:t>
+              <a:t>Page 5: Activity Options (with verified links)</a:t>
             </a:r>
           </a:p>
         </p:txBody>
@@ -6129,7 +6203,9 @@
           </a:fontRef>
         </p:style>
         <p:txBody>
-          <a:bodyPr rtlCol="0" anchor="ctr"/>
+          <a:bodyPr rtlCol="0" anchor="ctr" wrap="square">
+            <a:normAutofit/>
+          </a:bodyPr>
           <a:lstStyle/>
           <a:p>
             <a:pPr algn="ctr"/>
@@ -6172,7 +6248,9 @@
           </a:fontRef>
         </p:style>
         <p:txBody>
-          <a:bodyPr rtlCol="0" anchor="ctr"/>
+          <a:bodyPr rtlCol="0" anchor="ctr" wrap="square">
+            <a:normAutofit/>
+          </a:bodyPr>
           <a:lstStyle/>
           <a:p>
             <a:pPr algn="ctr"/>
@@ -6215,7 +6293,9 @@
           </a:fontRef>
         </p:style>
         <p:txBody>
-          <a:bodyPr rtlCol="0" anchor="ctr"/>
+          <a:bodyPr rtlCol="0" anchor="ctr" wrap="square">
+            <a:normAutofit/>
+          </a:bodyPr>
           <a:lstStyle/>
           <a:p>
             <a:pPr algn="ctr"/>
@@ -6258,7 +6338,9 @@
           </a:fontRef>
         </p:style>
         <p:txBody>
-          <a:bodyPr rtlCol="0" anchor="ctr"/>
+          <a:bodyPr rtlCol="0" anchor="ctr" wrap="square">
+            <a:normAutofit/>
+          </a:bodyPr>
           <a:lstStyle/>
           <a:p>
             <a:pPr algn="ctr"/>
@@ -6303,7 +6385,9 @@
           </a:fontRef>
         </p:style>
         <p:txBody>
-          <a:bodyPr rtlCol="0" anchor="ctr"/>
+          <a:bodyPr rtlCol="0" anchor="ctr" wrap="square">
+            <a:normAutofit/>
+          </a:bodyPr>
           <a:lstStyle/>
           <a:p>
             <a:pPr algn="ctr"/>
@@ -6348,7 +6432,9 @@
           </a:fontRef>
         </p:style>
         <p:txBody>
-          <a:bodyPr rtlCol="0" anchor="ctr"/>
+          <a:bodyPr rtlCol="0" anchor="ctr" wrap="square">
+            <a:normAutofit/>
+          </a:bodyPr>
           <a:lstStyle/>
           <a:p>
             <a:pPr algn="ctr"/>
@@ -6372,8 +6458,8 @@
           <a:noFill/>
         </p:spPr>
         <p:txBody>
-          <a:bodyPr wrap="none">
-            <a:spAutoFit/>
+          <a:bodyPr wrap="square">
+            <a:normAutofit/>
           </a:bodyPr>
           <a:lstStyle/>
           <a:p>
@@ -6391,7 +6477,7 @@
           </a:p>
           <a:p>
             <a:pPr>
-              <a:defRPr sz="1400" b="0">
+              <a:defRPr sz="1360" b="0">
                 <a:solidFill>
                   <a:srgbClr val="181818"/>
                 </a:solidFill>
@@ -6404,7 +6490,7 @@
           </a:p>
           <a:p>
             <a:pPr>
-              <a:defRPr sz="1400" b="0">
+              <a:defRPr sz="1360" b="0">
                 <a:solidFill>
                   <a:srgbClr val="181818"/>
                 </a:solidFill>
@@ -6412,12 +6498,12 @@
               </a:defRPr>
             </a:pPr>
             <a:r>
-              <a:t>   Purpose: Learn efficient AI-supported pipeline in real client-facing projects.</a:t>
+              <a:t>   Purpose: Learn an efficient AI-supported pipeline in client-facing projects.</a:t>
             </a:r>
           </a:p>
           <a:p>
             <a:pPr>
-              <a:defRPr sz="1400" b="0">
+              <a:defRPr sz="1360" b="0">
                 <a:solidFill>
                   <a:srgbClr val="181818"/>
                 </a:solidFill>
@@ -6425,7 +6511,7 @@
               </a:defRPr>
             </a:pPr>
             <a:r>
-              <a:t>   Rationale: Highest relevance to my planned career pathway in China.</a:t>
+              <a:t>   Rationale: highest relevance to my planned career pathway in China.</a:t>
             </a:r>
           </a:p>
           <a:p>
@@ -6438,12 +6524,12 @@
               </a:defRPr>
             </a:pPr>
             <a:r>
-              <a:t>2) UAL / RCA Summer School (real links)</a:t>
-            </a:r>
-          </a:p>
-          <a:p>
-            <a:r>
-              <a:rPr sz="1350">
+              <a:t>2) UAL / RCA Summer School (verified links)</a:t>
+            </a:r>
+          </a:p>
+          <a:p>
+            <a:r>
+              <a:rPr sz="1320">
                 <a:solidFill>
                   <a:srgbClr val="3263BE"/>
                 </a:solidFill>
@@ -6455,7 +6541,7 @@
           </a:p>
           <a:p>
             <a:r>
-              <a:rPr sz="1350">
+              <a:rPr sz="1320">
                 <a:solidFill>
                   <a:srgbClr val="3263BE"/>
                 </a:solidFill>
@@ -6480,7 +6566,7 @@
           </a:p>
           <a:p>
             <a:pPr>
-              <a:defRPr sz="1400" b="0">
+              <a:defRPr sz="1360" b="0">
                 <a:solidFill>
                   <a:srgbClr val="181818"/>
                 </a:solidFill>
@@ -6488,12 +6574,12 @@
               </a:defRPr>
             </a:pPr>
             <a:r>
-              <a:t>   Focus: 3D printing / architecture-related studio practice.</a:t>
+              <a:t>   Focus: 3D printing and architecture-related studio practice.</a:t>
             </a:r>
           </a:p>
           <a:p>
             <a:pPr>
-              <a:defRPr sz="1400" b="0">
+              <a:defRPr sz="1360" b="0">
                 <a:solidFill>
                   <a:srgbClr val="181818"/>
                 </a:solidFill>
@@ -6501,7 +6587,7 @@
               </a:defRPr>
             </a:pPr>
             <a:r>
-              <a:t>   Value: Hands-on making and spatial design experience.</a:t>
+              <a:t>   Value: hands-on making and spatial design experience.</a:t>
             </a:r>
           </a:p>
         </p:txBody>
@@ -6523,8 +6609,8 @@
           <a:noFill/>
         </p:spPr>
         <p:txBody>
-          <a:bodyPr wrap="none">
-            <a:spAutoFit/>
+          <a:bodyPr wrap="square">
+            <a:normAutofit/>
           </a:bodyPr>
           <a:lstStyle/>
           <a:p>
@@ -6559,13 +6645,13 @@
           <a:noFill/>
         </p:spPr>
         <p:txBody>
-          <a:bodyPr wrap="none">
-            <a:spAutoFit/>
+          <a:bodyPr wrap="square">
+            <a:normAutofit/>
           </a:bodyPr>
           <a:lstStyle/>
           <a:p>
             <a:pPr>
-              <a:defRPr sz="1350" b="0">
+              <a:defRPr sz="1330" b="0">
                 <a:solidFill>
                   <a:srgbClr val="181818"/>
                 </a:solidFill>
@@ -6578,7 +6664,7 @@
           </a:p>
           <a:p>
             <a:pPr>
-              <a:defRPr sz="1350" b="0">
+              <a:defRPr sz="1330" b="0">
                 <a:solidFill>
                   <a:srgbClr val="181818"/>
                 </a:solidFill>
@@ -6591,7 +6677,7 @@
           </a:p>
           <a:p>
             <a:pPr>
-              <a:defRPr sz="1350" b="0">
+              <a:defRPr sz="1330" b="0">
                 <a:solidFill>
                   <a:srgbClr val="181818"/>
                 </a:solidFill>
@@ -6604,7 +6690,7 @@
           </a:p>
           <a:p>
             <a:pPr>
-              <a:defRPr sz="1350" b="0">
+              <a:defRPr sz="1330" b="0">
                 <a:solidFill>
                   <a:srgbClr val="181818"/>
                 </a:solidFill>
@@ -6612,12 +6698,12 @@
               </a:defRPr>
             </a:pPr>
             <a:r>
-              <a:t>• Visa/time feasibility</a:t>
+              <a:t>• Visa and time feasibility</a:t>
             </a:r>
           </a:p>
           <a:p>
             <a:pPr>
-              <a:defRPr sz="1350" b="0">
+              <a:defRPr sz="1330" b="0">
                 <a:solidFill>
                   <a:srgbClr val="181818"/>
                 </a:solidFill>
@@ -6630,7 +6716,7 @@
           </a:p>
           <a:p>
             <a:pPr>
-              <a:defRPr sz="1350" b="0">
+              <a:defRPr sz="1330" b="0">
                 <a:solidFill>
                   <a:srgbClr val="181818"/>
                 </a:solidFill>
@@ -6643,7 +6729,7 @@
           </a:p>
           <a:p>
             <a:pPr>
-              <a:defRPr sz="1350" b="0">
+              <a:defRPr sz="1330" b="0">
                 <a:solidFill>
                   <a:srgbClr val="181818"/>
                 </a:solidFill>
@@ -6653,7 +6739,7 @@
           </a:p>
           <a:p>
             <a:pPr>
-              <a:defRPr sz="1350" b="1">
+              <a:defRPr sz="1330" b="1">
                 <a:solidFill>
                   <a:srgbClr val="181818"/>
                 </a:solidFill>
@@ -6666,7 +6752,7 @@
           </a:p>
           <a:p>
             <a:pPr>
-              <a:defRPr sz="1350" b="0">
+              <a:defRPr sz="1330" b="0">
                 <a:solidFill>
                   <a:srgbClr val="181818"/>
                 </a:solidFill>
@@ -6679,7 +6765,7 @@
           </a:p>
           <a:p>
             <a:pPr>
-              <a:defRPr sz="1350" b="0">
+              <a:defRPr sz="1330" b="0">
                 <a:solidFill>
                   <a:srgbClr val="181818"/>
                 </a:solidFill>
@@ -6692,7 +6778,7 @@
           </a:p>
           <a:p>
             <a:pPr>
-              <a:defRPr sz="1350" b="0">
+              <a:defRPr sz="1330" b="0">
                 <a:solidFill>
                   <a:srgbClr val="181818"/>
                 </a:solidFill>
@@ -6767,7 +6853,9 @@
           </a:fontRef>
         </p:style>
         <p:txBody>
-          <a:bodyPr rtlCol="0" anchor="ctr"/>
+          <a:bodyPr rtlCol="0" anchor="ctr" wrap="square">
+            <a:normAutofit/>
+          </a:bodyPr>
           <a:lstStyle/>
           <a:p>
             <a:pPr algn="ctr"/>
@@ -6810,7 +6898,9 @@
           </a:fontRef>
         </p:style>
         <p:txBody>
-          <a:bodyPr rtlCol="0" anchor="ctr"/>
+          <a:bodyPr rtlCol="0" anchor="ctr" wrap="square">
+            <a:normAutofit/>
+          </a:bodyPr>
           <a:lstStyle/>
           <a:p>
             <a:pPr algn="ctr"/>
@@ -6853,7 +6943,9 @@
           </a:fontRef>
         </p:style>
         <p:txBody>
-          <a:bodyPr rtlCol="0" anchor="ctr"/>
+          <a:bodyPr rtlCol="0" anchor="ctr" wrap="square">
+            <a:normAutofit/>
+          </a:bodyPr>
           <a:lstStyle/>
           <a:p>
             <a:pPr algn="ctr"/>
@@ -6896,7 +6988,9 @@
           </a:fontRef>
         </p:style>
         <p:txBody>
-          <a:bodyPr rtlCol="0" anchor="ctr"/>
+          <a:bodyPr rtlCol="0" anchor="ctr" wrap="square">
+            <a:normAutofit/>
+          </a:bodyPr>
           <a:lstStyle/>
           <a:p>
             <a:pPr algn="ctr"/>
@@ -6920,8 +7014,8 @@
           <a:noFill/>
         </p:spPr>
         <p:txBody>
-          <a:bodyPr wrap="none">
-            <a:spAutoFit/>
+          <a:bodyPr wrap="square">
+            <a:normAutofit/>
           </a:bodyPr>
           <a:lstStyle/>
           <a:p>
@@ -6956,13 +7050,13 @@
           <a:noFill/>
         </p:spPr>
         <p:txBody>
-          <a:bodyPr wrap="none">
-            <a:spAutoFit/>
+          <a:bodyPr wrap="square">
+            <a:normAutofit/>
           </a:bodyPr>
           <a:lstStyle/>
           <a:p>
             <a:pPr>
-              <a:defRPr sz="3500" b="1">
+              <a:defRPr sz="3300" b="1">
                 <a:solidFill>
                   <a:srgbClr val="181818"/>
                 </a:solidFill>
@@ -6970,7 +7064,7 @@
               </a:defRPr>
             </a:pPr>
             <a:r>
-              <a:t>Page 6 Timeline 时间线</a:t>
+              <a:t>Page 6: Timeline</a:t>
             </a:r>
           </a:p>
         </p:txBody>
@@ -7011,7 +7105,9 @@
           </a:fontRef>
         </p:style>
         <p:txBody>
-          <a:bodyPr rtlCol="0" anchor="ctr"/>
+          <a:bodyPr rtlCol="0" anchor="ctr" wrap="square">
+            <a:normAutofit/>
+          </a:bodyPr>
           <a:lstStyle/>
           <a:p>
             <a:pPr algn="ctr"/>
@@ -7054,7 +7150,9 @@
           </a:fontRef>
         </p:style>
         <p:txBody>
-          <a:bodyPr rtlCol="0" anchor="ctr"/>
+          <a:bodyPr rtlCol="0" anchor="ctr" wrap="square">
+            <a:normAutofit/>
+          </a:bodyPr>
           <a:lstStyle/>
           <a:p>
             <a:pPr algn="ctr"/>
@@ -7097,7 +7195,9 @@
           </a:fontRef>
         </p:style>
         <p:txBody>
-          <a:bodyPr rtlCol="0" anchor="ctr"/>
+          <a:bodyPr rtlCol="0" anchor="ctr" wrap="square">
+            <a:normAutofit/>
+          </a:bodyPr>
           <a:lstStyle/>
           <a:p>
             <a:pPr algn="ctr"/>
@@ -7140,7 +7240,9 @@
           </a:fontRef>
         </p:style>
         <p:txBody>
-          <a:bodyPr rtlCol="0" anchor="ctr"/>
+          <a:bodyPr rtlCol="0" anchor="ctr" wrap="square">
+            <a:normAutofit/>
+          </a:bodyPr>
           <a:lstStyle/>
           <a:p>
             <a:pPr algn="ctr"/>
@@ -7164,8 +7266,8 @@
           <a:noFill/>
         </p:spPr>
         <p:txBody>
-          <a:bodyPr wrap="none">
-            <a:spAutoFit/>
+          <a:bodyPr wrap="square">
+            <a:normAutofit/>
           </a:bodyPr>
           <a:lstStyle/>
           <a:p>
@@ -7178,47 +7280,47 @@
               </a:defRPr>
             </a:pPr>
             <a:r>
-              <a:t>April – June: Preparation Phase</a:t>
+              <a:t>April to June: Preparation Phase</a:t>
             </a:r>
           </a:p>
           <a:p>
             <a:pPr>
-              <a:defRPr sz="1350">
+              <a:defRPr sz="1340">
                 <a:latin typeface="Arial"/>
               </a:defRPr>
             </a:pPr>
             <a:r>
-              <a:t>• Complete university coursework and define project focus</a:t>
+              <a:t>• Complete university coursework and define project focus.</a:t>
             </a:r>
           </a:p>
           <a:p>
             <a:pPr>
-              <a:defRPr sz="1350">
+              <a:defRPr sz="1340">
                 <a:latin typeface="Arial"/>
               </a:defRPr>
             </a:pPr>
             <a:r>
-              <a:t>• Update CV and portfolio with targeted case studies</a:t>
+              <a:t>• Update CV and portfolio with targeted case studies.</a:t>
             </a:r>
           </a:p>
           <a:p>
             <a:pPr>
-              <a:defRPr sz="1350">
+              <a:defRPr sz="1340">
                 <a:latin typeface="Arial"/>
               </a:defRPr>
             </a:pPr>
             <a:r>
-              <a:t>• Submit internship/summer-school applications and attend interviews</a:t>
+              <a:t>• Submit applications and attend internship or school interviews.</a:t>
             </a:r>
           </a:p>
           <a:p>
             <a:pPr>
-              <a:defRPr sz="1350">
+              <a:defRPr sz="1340">
                 <a:latin typeface="Arial"/>
               </a:defRPr>
             </a:pPr>
             <a:r>
-              <a:t>• Build reflective research log and application tracker</a:t>
+              <a:t>• Build a reflective research log and application tracker.</a:t>
             </a:r>
           </a:p>
         </p:txBody>
@@ -7240,8 +7342,8 @@
           <a:noFill/>
         </p:spPr>
         <p:txBody>
-          <a:bodyPr wrap="none">
-            <a:spAutoFit/>
+          <a:bodyPr wrap="square">
+            <a:normAutofit/>
           </a:bodyPr>
           <a:lstStyle/>
           <a:p>
@@ -7254,37 +7356,37 @@
               </a:defRPr>
             </a:pPr>
             <a:r>
-              <a:t>July – September: Implementation Phase</a:t>
+              <a:t>July to September: Implementation Phase</a:t>
             </a:r>
           </a:p>
           <a:p>
             <a:pPr>
-              <a:defRPr sz="1350">
+              <a:defRPr sz="1340">
                 <a:latin typeface="Arial"/>
               </a:defRPr>
             </a:pPr>
             <a:r>
-              <a:t>• Start internship / summer school and document workflow learning</a:t>
+              <a:t>• Start internship or summer school and document workflow learning.</a:t>
             </a:r>
           </a:p>
           <a:p>
             <a:pPr>
-              <a:defRPr sz="1350">
+              <a:defRPr sz="1340">
                 <a:latin typeface="Arial"/>
               </a:defRPr>
             </a:pPr>
             <a:r>
-              <a:t>• Continue part-time photography and editing for applied practice</a:t>
+              <a:t>• Continue part-time photography and editing for applied practice.</a:t>
             </a:r>
           </a:p>
           <a:p>
             <a:pPr>
-              <a:defRPr sz="1350">
+              <a:defRPr sz="1340">
                 <a:latin typeface="Arial"/>
               </a:defRPr>
             </a:pPr>
             <a:r>
-              <a:t>• Conduct mid-point self-evaluation and final portfolio consolidation</a:t>
+              <a:t>• Conduct mid-point review and final portfolio consolidation.</a:t>
             </a:r>
           </a:p>
         </p:txBody>
@@ -7351,7 +7453,9 @@
           </a:fontRef>
         </p:style>
         <p:txBody>
-          <a:bodyPr rtlCol="0" anchor="ctr"/>
+          <a:bodyPr rtlCol="0" anchor="ctr" wrap="square">
+            <a:normAutofit/>
+          </a:bodyPr>
           <a:lstStyle/>
           <a:p>
             <a:pPr algn="ctr"/>
@@ -7394,7 +7498,9 @@
           </a:fontRef>
         </p:style>
         <p:txBody>
-          <a:bodyPr rtlCol="0" anchor="ctr"/>
+          <a:bodyPr rtlCol="0" anchor="ctr" wrap="square">
+            <a:normAutofit/>
+          </a:bodyPr>
           <a:lstStyle/>
           <a:p>
             <a:pPr algn="ctr"/>
@@ -7437,7 +7543,9 @@
           </a:fontRef>
         </p:style>
         <p:txBody>
-          <a:bodyPr rtlCol="0" anchor="ctr"/>
+          <a:bodyPr rtlCol="0" anchor="ctr" wrap="square">
+            <a:normAutofit/>
+          </a:bodyPr>
           <a:lstStyle/>
           <a:p>
             <a:pPr algn="ctr"/>
@@ -7480,7 +7588,9 @@
           </a:fontRef>
         </p:style>
         <p:txBody>
-          <a:bodyPr rtlCol="0" anchor="ctr"/>
+          <a:bodyPr rtlCol="0" anchor="ctr" wrap="square">
+            <a:normAutofit/>
+          </a:bodyPr>
           <a:lstStyle/>
           <a:p>
             <a:pPr algn="ctr"/>
@@ -7504,8 +7614,8 @@
           <a:noFill/>
         </p:spPr>
         <p:txBody>
-          <a:bodyPr wrap="none">
-            <a:spAutoFit/>
+          <a:bodyPr wrap="square">
+            <a:normAutofit/>
           </a:bodyPr>
           <a:lstStyle/>
           <a:p>
@@ -7540,13 +7650,13 @@
           <a:noFill/>
         </p:spPr>
         <p:txBody>
-          <a:bodyPr wrap="none">
-            <a:spAutoFit/>
+          <a:bodyPr wrap="square">
+            <a:normAutofit/>
           </a:bodyPr>
           <a:lstStyle/>
           <a:p>
             <a:pPr>
-              <a:defRPr sz="3500" b="1">
+              <a:defRPr sz="3300" b="1">
                 <a:solidFill>
                   <a:srgbClr val="181818"/>
                 </a:solidFill>
@@ -7554,7 +7664,7 @@
               </a:defRPr>
             </a:pPr>
             <a:r>
-              <a:t>Page 7 Feasibility &amp; Preparation 可行性与准备</a:t>
+              <a:t>Page 7: Feasibility and Preparation</a:t>
             </a:r>
           </a:p>
         </p:txBody>
@@ -7595,7 +7705,9 @@
           </a:fontRef>
         </p:style>
         <p:txBody>
-          <a:bodyPr rtlCol="0" anchor="ctr"/>
+          <a:bodyPr rtlCol="0" anchor="ctr" wrap="square">
+            <a:normAutofit/>
+          </a:bodyPr>
           <a:lstStyle/>
           <a:p>
             <a:pPr algn="ctr"/>
@@ -7638,7 +7750,9 @@
           </a:fontRef>
         </p:style>
         <p:txBody>
-          <a:bodyPr rtlCol="0" anchor="ctr"/>
+          <a:bodyPr rtlCol="0" anchor="ctr" wrap="square">
+            <a:normAutofit/>
+          </a:bodyPr>
           <a:lstStyle/>
           <a:p>
             <a:pPr algn="ctr"/>
@@ -7681,7 +7795,9 @@
           </a:fontRef>
         </p:style>
         <p:txBody>
-          <a:bodyPr rtlCol="0" anchor="ctr"/>
+          <a:bodyPr rtlCol="0" anchor="ctr" wrap="square">
+            <a:normAutofit/>
+          </a:bodyPr>
           <a:lstStyle/>
           <a:p>
             <a:pPr algn="ctr"/>
@@ -7724,7 +7840,9 @@
           </a:fontRef>
         </p:style>
         <p:txBody>
-          <a:bodyPr rtlCol="0" anchor="ctr"/>
+          <a:bodyPr rtlCol="0" anchor="ctr" wrap="square">
+            <a:normAutofit/>
+          </a:bodyPr>
           <a:lstStyle/>
           <a:p>
             <a:pPr algn="ctr"/>
@@ -7748,8 +7866,8 @@
           <a:noFill/>
         </p:spPr>
         <p:txBody>
-          <a:bodyPr wrap="none">
-            <a:spAutoFit/>
+          <a:bodyPr wrap="square">
+            <a:normAutofit/>
           </a:bodyPr>
           <a:lstStyle/>
           <a:p>
@@ -7784,8 +7902,8 @@
           <a:noFill/>
         </p:spPr>
         <p:txBody>
-          <a:bodyPr wrap="none">
-            <a:spAutoFit/>
+          <a:bodyPr wrap="square">
+            <a:normAutofit/>
           </a:bodyPr>
           <a:lstStyle/>
           <a:p>
@@ -7801,7 +7919,7 @@
               </a:defRPr>
             </a:pPr>
             <a:r>
-              <a:t>• Location: London is feasible within current international student visa conditions.</a:t>
+              <a:t>• Location: London remains feasible under current international student visa conditions.</a:t>
             </a:r>
           </a:p>
           <a:p>
@@ -7817,7 +7935,7 @@
               </a:defRPr>
             </a:pPr>
             <a:r>
-              <a:t>• Resources: portfolio revision plan, application email templates, and AI studio shortlist are prepared.</a:t>
+              <a:t>• Resources: portfolio revision plan, application templates, and AI studio shortlist are prepared.</a:t>
             </a:r>
           </a:p>
         </p:txBody>
@@ -7839,8 +7957,8 @@
           <a:noFill/>
         </p:spPr>
         <p:txBody>
-          <a:bodyPr wrap="none">
-            <a:spAutoFit/>
+          <a:bodyPr wrap="square">
+            <a:normAutofit/>
           </a:bodyPr>
           <a:lstStyle/>
           <a:p>
@@ -7875,8 +7993,8 @@
           <a:noFill/>
         </p:spPr>
         <p:txBody>
-          <a:bodyPr wrap="none">
-            <a:spAutoFit/>
+          <a:bodyPr wrap="square">
+            <a:normAutofit/>
           </a:bodyPr>
           <a:lstStyle/>
           <a:p>
@@ -7892,7 +8010,7 @@
               </a:defRPr>
             </a:pPr>
             <a:r>
-              <a:t>• Risk: internship competition and uncertain acceptance timelines.</a:t>
+              <a:t>• Risk: competition for internships and uncertain acceptance timelines.</a:t>
             </a:r>
           </a:p>
           <a:p>
@@ -7908,7 +8026,7 @@
               </a:defRPr>
             </a:pPr>
             <a:r>
-              <a:t>• Mitigation: parallel applications (internship + summer school + studio option) and phased decision points.</a:t>
+              <a:t>• Mitigation: parallel applications across internship, summer school, and studio options.</a:t>
             </a:r>
           </a:p>
         </p:txBody>
@@ -7930,8 +8048,8 @@
           <a:noFill/>
         </p:spPr>
         <p:txBody>
-          <a:bodyPr wrap="none">
-            <a:spAutoFit/>
+          <a:bodyPr wrap="square">
+            <a:normAutofit/>
           </a:bodyPr>
           <a:lstStyle/>
           <a:p>
@@ -7944,7 +8062,7 @@
               </a:defRPr>
             </a:pPr>
             <a:r>
-              <a:t>Ethics &amp; Professional Standards</a:t>
+              <a:t>Ethics and Professional Standards</a:t>
             </a:r>
           </a:p>
         </p:txBody>
@@ -7966,8 +8084,8 @@
           <a:noFill/>
         </p:spPr>
         <p:txBody>
-          <a:bodyPr wrap="none">
-            <a:spAutoFit/>
+          <a:bodyPr wrap="square">
+            <a:normAutofit/>
           </a:bodyPr>
           <a:lstStyle/>
           <a:p>
@@ -7983,7 +8101,7 @@
               </a:defRPr>
             </a:pPr>
             <a:r>
-              <a:t>• Address AI-related concerns on authorship, bias, and data provenance in project documentation.</a:t>
+              <a:t>• Address authorship, bias, and data provenance when using AI-assisted workflows.</a:t>
             </a:r>
           </a:p>
           <a:p>
@@ -7999,7 +8117,7 @@
               </a:defRPr>
             </a:pPr>
             <a:r>
-              <a:t>• Maintain reflective records to evidence critical decision-making, not only technical output.</a:t>
+              <a:t>• Maintain reflective documentation to evidence critical decisions, not only output.</a:t>
             </a:r>
           </a:p>
         </p:txBody>
@@ -8021,8 +8139,8 @@
           <a:noFill/>
         </p:spPr>
         <p:txBody>
-          <a:bodyPr wrap="none">
-            <a:spAutoFit/>
+          <a:bodyPr wrap="square">
+            <a:normAutofit/>
           </a:bodyPr>
           <a:lstStyle/>
           <a:p>
@@ -8057,8 +8175,8 @@
           <a:noFill/>
         </p:spPr>
         <p:txBody>
-          <a:bodyPr wrap="none">
-            <a:spAutoFit/>
+          <a:bodyPr wrap="square">
+            <a:normAutofit/>
           </a:bodyPr>
           <a:lstStyle/>
           <a:p>
@@ -8074,7 +8192,7 @@
               </a:defRPr>
             </a:pPr>
             <a:r>
-              <a:t>• Internship/study activities can be combined with part-time creative work to maintain continuity.</a:t>
+              <a:t>• Internship or study activities can be combined with part-time creative work.</a:t>
             </a:r>
           </a:p>
         </p:txBody>
@@ -8141,7 +8259,9 @@
           </a:fontRef>
         </p:style>
         <p:txBody>
-          <a:bodyPr rtlCol="0" anchor="ctr"/>
+          <a:bodyPr rtlCol="0" anchor="ctr" wrap="square">
+            <a:normAutofit/>
+          </a:bodyPr>
           <a:lstStyle/>
           <a:p>
             <a:pPr algn="ctr"/>
@@ -8184,7 +8304,9 @@
           </a:fontRef>
         </p:style>
         <p:txBody>
-          <a:bodyPr rtlCol="0" anchor="ctr"/>
+          <a:bodyPr rtlCol="0" anchor="ctr" wrap="square">
+            <a:normAutofit/>
+          </a:bodyPr>
           <a:lstStyle/>
           <a:p>
             <a:pPr algn="ctr"/>
@@ -8227,7 +8349,9 @@
           </a:fontRef>
         </p:style>
         <p:txBody>
-          <a:bodyPr rtlCol="0" anchor="ctr"/>
+          <a:bodyPr rtlCol="0" anchor="ctr" wrap="square">
+            <a:normAutofit/>
+          </a:bodyPr>
           <a:lstStyle/>
           <a:p>
             <a:pPr algn="ctr"/>
@@ -8270,7 +8394,9 @@
           </a:fontRef>
         </p:style>
         <p:txBody>
-          <a:bodyPr rtlCol="0" anchor="ctr"/>
+          <a:bodyPr rtlCol="0" anchor="ctr" wrap="square">
+            <a:normAutofit/>
+          </a:bodyPr>
           <a:lstStyle/>
           <a:p>
             <a:pPr algn="ctr"/>
@@ -8294,8 +8420,8 @@
           <a:noFill/>
         </p:spPr>
         <p:txBody>
-          <a:bodyPr wrap="none">
-            <a:spAutoFit/>
+          <a:bodyPr wrap="square">
+            <a:normAutofit/>
           </a:bodyPr>
           <a:lstStyle/>
           <a:p>
@@ -8330,13 +8456,13 @@
           <a:noFill/>
         </p:spPr>
         <p:txBody>
-          <a:bodyPr wrap="none">
-            <a:spAutoFit/>
+          <a:bodyPr wrap="square">
+            <a:normAutofit/>
           </a:bodyPr>
           <a:lstStyle/>
           <a:p>
             <a:pPr>
-              <a:defRPr sz="3500" b="1">
+              <a:defRPr sz="3300" b="1">
                 <a:solidFill>
                   <a:srgbClr val="181818"/>
                 </a:solidFill>
@@ -8344,7 +8470,7 @@
               </a:defRPr>
             </a:pPr>
             <a:r>
-              <a:t>Page 8 Conclusion 总结</a:t>
+              <a:t>Page 8: Conclusion</a:t>
             </a:r>
           </a:p>
         </p:txBody>
@@ -8385,7 +8511,9 @@
           </a:fontRef>
         </p:style>
         <p:txBody>
-          <a:bodyPr rtlCol="0" anchor="ctr"/>
+          <a:bodyPr rtlCol="0" anchor="ctr" wrap="square">
+            <a:normAutofit/>
+          </a:bodyPr>
           <a:lstStyle/>
           <a:p>
             <a:pPr algn="ctr"/>
@@ -8430,7 +8558,9 @@
           </a:fontRef>
         </p:style>
         <p:txBody>
-          <a:bodyPr rtlCol="0" anchor="ctr"/>
+          <a:bodyPr rtlCol="0" anchor="ctr" wrap="square">
+            <a:normAutofit/>
+          </a:bodyPr>
           <a:lstStyle/>
           <a:p>
             <a:pPr algn="ctr"/>
@@ -8454,14 +8584,14 @@
           <a:noFill/>
         </p:spPr>
         <p:txBody>
-          <a:bodyPr wrap="none">
-            <a:spAutoFit/>
+          <a:bodyPr wrap="square">
+            <a:normAutofit/>
           </a:bodyPr>
           <a:lstStyle/>
           <a:p>
             <a:pPr>
               <a:spcAft>
-                <a:spcPts val="1000"/>
+                <a:spcPts val="900"/>
               </a:spcAft>
               <a:defRPr sz="2000" b="1">
                 <a:solidFill>
@@ -8477,9 +8607,9 @@
           <a:p>
             <a:pPr>
               <a:spcAft>
-                <a:spcPts val="1000"/>
+                <a:spcPts val="900"/>
               </a:spcAft>
-              <a:defRPr sz="1700" b="0">
+              <a:defRPr sz="1650" b="0">
                 <a:solidFill>
                   <a:srgbClr val="181818"/>
                 </a:solidFill>
@@ -8487,15 +8617,15 @@
               </a:defRPr>
             </a:pPr>
             <a:r>
-              <a:t>It links critical reflection with professional experimentation to clarify my creative direction and career identity.</a:t>
+              <a:t>It combines critical reflection with professional experimentation to clarify my creative direction and career identity.</a:t>
             </a:r>
           </a:p>
           <a:p>
             <a:pPr>
               <a:spcAft>
-                <a:spcPts val="1000"/>
+                <a:spcPts val="900"/>
               </a:spcAft>
-              <a:defRPr sz="1700" b="0">
+              <a:defRPr sz="1650" b="0">
                 <a:solidFill>
                   <a:srgbClr val="181818"/>
                 </a:solidFill>
@@ -8503,15 +8633,15 @@
               </a:defRPr>
             </a:pPr>
             <a:r>
-              <a:t>By combining internships, summer programmes, and independent practice, the project will produce measurable outcomes: improved technical fluency, stronger portfolio evidence, and expanded industry networks.</a:t>
+              <a:t>By integrating internships, summer programmes, and independent practice, the project targets measurable outcomes: stronger technical fluency, improved portfolio evidence, and expanded industry networks.</a:t>
             </a:r>
           </a:p>
           <a:p>
             <a:pPr>
               <a:spcAft>
-                <a:spcPts val="1000"/>
+                <a:spcPts val="900"/>
               </a:spcAft>
-              <a:defRPr sz="1700" b="0">
+              <a:defRPr sz="1650" b="0">
                 <a:solidFill>
                   <a:srgbClr val="181818"/>
                 </a:solidFill>
@@ -8519,7 +8649,7 @@
               </a:defRPr>
             </a:pPr>
             <a:r>
-              <a:t>Ultimately, the study supports a transition toward future-facing design or AI operation roles in China with both conceptual depth and practical readiness.</a:t>
+              <a:t>Ultimately, the study supports my transition into future-facing design or AI operation roles in China with both conceptual depth and practical readiness.</a:t>
             </a:r>
           </a:p>
         </p:txBody>
@@ -8560,7 +8690,9 @@
           </a:fontRef>
         </p:style>
         <p:txBody>
-          <a:bodyPr rtlCol="0" anchor="ctr"/>
+          <a:bodyPr rtlCol="0" anchor="ctr" wrap="square">
+            <a:normAutofit/>
+          </a:bodyPr>
           <a:lstStyle/>
           <a:p>
             <a:pPr algn="ctr"/>
@@ -8603,7 +8735,9 @@
           </a:fontRef>
         </p:style>
         <p:txBody>
-          <a:bodyPr rtlCol="0" anchor="ctr"/>
+          <a:bodyPr rtlCol="0" anchor="ctr" wrap="square">
+            <a:normAutofit/>
+          </a:bodyPr>
           <a:lstStyle/>
           <a:p>
             <a:pPr algn="ctr"/>
@@ -8646,7 +8780,9 @@
           </a:fontRef>
         </p:style>
         <p:txBody>
-          <a:bodyPr rtlCol="0" anchor="ctr"/>
+          <a:bodyPr rtlCol="0" anchor="ctr" wrap="square">
+            <a:normAutofit/>
+          </a:bodyPr>
           <a:lstStyle/>
           <a:p>
             <a:pPr algn="ctr"/>

</xml_diff>